<commit_message>
docs: remove ablation-study numbers from Innovation slide, headline the 29.10 dB result there too
The 27.0756/27.7637 ablation figures (legitimate v1 methodology data)
were the first PSNR numbers a reader saw, before reaching the Results
slide with the real 29.10 dB submitted score. Removed the ablation
block and put the actual headline result on this slide as well.
</commit_message>
<xml_diff>
--- a/StarkIndustries_KLA_PS01.pptx
+++ b/StarkIndustries_KLA_PS01.pptx
@@ -7378,22 +7378,22 @@
       </p:sp>
       <p:sp>
         <p:nvSpPr>
-          <p:cNvPr id="17" name="Shape 11">
-            <a:extLst xmlns:a="http://schemas.openxmlformats.org/drawingml/2006/main">
-              <a:ext uri="{FF2B5EF4-FFF2-40B4-BE49-F238E27FC236}">
-                <a16:creationId xmlns:a16="http://schemas.microsoft.com/office/drawing/2014/main" id="{8C40B548-7810-4370-A45F-C15D0A47646E}"/>
-              </a:ext>
-            </a:extLst>
-          </p:cNvPr>
-          <p:cNvSpPr>
-            <a:spLocks xmlns:a="http://schemas.openxmlformats.org/drawingml/2006/main" noGrp="1"/>
-          </p:cNvSpPr>
-          <p:nvPr/>
-        </p:nvSpPr>
-        <p:spPr>
-          <a:xfrm xmlns:a="http://schemas.openxmlformats.org/drawingml/2006/main">
-            <a:off x="961949" y="3845052"/>
-            <a:ext cx="5020056" cy="1429207"/>
+          <p:cNvPr id="20" name="Shape 14">
+            <a:extLst xmlns:a="http://schemas.openxmlformats.org/drawingml/2006/main">
+              <a:ext uri="{FF2B5EF4-FFF2-40B4-BE49-F238E27FC236}">
+                <a16:creationId xmlns:a16="http://schemas.microsoft.com/office/drawing/2014/main" id="{A5515EF3-1027-4657-B6B7-C43C9F385264}"/>
+              </a:ext>
+            </a:extLst>
+          </p:cNvPr>
+          <p:cNvSpPr>
+            <a:spLocks xmlns:a="http://schemas.openxmlformats.org/drawingml/2006/main" noGrp="1"/>
+          </p:cNvSpPr>
+          <p:nvPr/>
+        </p:nvSpPr>
+        <p:spPr>
+          <a:xfrm xmlns:a="http://schemas.openxmlformats.org/drawingml/2006/main">
+            <a:off x="960120" y="3845052"/>
+            <a:ext cx="10268712" cy="1429207"/>
           </a:xfrm>
           <a:prstGeom xmlns:a="http://schemas.openxmlformats.org/drawingml/2006/main" prst="roundRect">
             <a:avLst>
@@ -7422,22 +7422,22 @@
       </p:sp>
       <p:sp>
         <p:nvSpPr>
-          <p:cNvPr id="18" name="Text 12">
-            <a:extLst xmlns:a="http://schemas.openxmlformats.org/drawingml/2006/main">
-              <a:ext uri="{FF2B5EF4-FFF2-40B4-BE49-F238E27FC236}">
-                <a16:creationId xmlns:a16="http://schemas.microsoft.com/office/drawing/2014/main" id="{66677ED8-8EB3-49F3-874E-C511B9E5C7D9}"/>
-              </a:ext>
-            </a:extLst>
-          </p:cNvPr>
-          <p:cNvSpPr>
-            <a:spLocks xmlns:a="http://schemas.openxmlformats.org/drawingml/2006/main" noGrp="1"/>
-          </p:cNvSpPr>
-          <p:nvPr/>
-        </p:nvSpPr>
-        <p:spPr>
-          <a:xfrm xmlns:a="http://schemas.openxmlformats.org/drawingml/2006/main">
-            <a:off x="1200607" y="4082796"/>
-            <a:ext cx="1271930" cy="191110"/>
+          <p:cNvPr id="21" name="Text 15">
+            <a:extLst xmlns:a="http://schemas.openxmlformats.org/drawingml/2006/main">
+              <a:ext uri="{FF2B5EF4-FFF2-40B4-BE49-F238E27FC236}">
+                <a16:creationId xmlns:a16="http://schemas.microsoft.com/office/drawing/2014/main" id="{73B7CA59-9D34-409C-B85B-2D1D05628FFC}"/>
+              </a:ext>
+            </a:extLst>
+          </p:cNvPr>
+          <p:cNvSpPr>
+            <a:spLocks xmlns:a="http://schemas.openxmlformats.org/drawingml/2006/main" noGrp="1"/>
+          </p:cNvSpPr>
+          <p:nvPr/>
+        </p:nvSpPr>
+        <p:spPr>
+          <a:xfrm xmlns:a="http://schemas.openxmlformats.org/drawingml/2006/main">
+            <a:off x="1197864" y="4082796"/>
+            <a:ext cx="5486400" cy="191110"/>
           </a:xfrm>
           <a:prstGeom xmlns:a="http://schemas.openxmlformats.org/drawingml/2006/main" prst="rect">
             <a:avLst/>
@@ -7460,7 +7460,7 @@
                 <a:ea typeface="Poppins"/>
                 <a:cs typeface="Poppins"/>
               </a:rPr>
-              <a:t>CONTROLLED 3x3 -&gt; 5x5 ABLATION</a:t>
+              <a:t>FINAL MODEL (EdgeRestore v2, submitted)</a:t>
             </a:r>
             <a:endParaRPr sz="1000"/>
           </a:p>
@@ -7468,22 +7468,22 @@
       </p:sp>
       <p:sp>
         <p:nvSpPr>
-          <p:cNvPr id="19" name="Text 13">
-            <a:extLst xmlns:a="http://schemas.openxmlformats.org/drawingml/2006/main">
-              <a:ext uri="{FF2B5EF4-FFF2-40B4-BE49-F238E27FC236}">
-                <a16:creationId xmlns:a16="http://schemas.microsoft.com/office/drawing/2014/main" id="{F880E284-9A49-43B3-B38C-13B8FB2562CE}"/>
-              </a:ext>
-            </a:extLst>
-          </p:cNvPr>
-          <p:cNvSpPr>
-            <a:spLocks xmlns:a="http://schemas.openxmlformats.org/drawingml/2006/main" noGrp="1"/>
-          </p:cNvSpPr>
-          <p:nvPr/>
-        </p:nvSpPr>
-        <p:spPr>
-          <a:xfrm xmlns:a="http://schemas.openxmlformats.org/drawingml/2006/main">
-            <a:off x="1200607" y="4349801"/>
-            <a:ext cx="4429354" cy="448056"/>
+          <p:cNvPr id="22" name="Text 16">
+            <a:extLst xmlns:a="http://schemas.openxmlformats.org/drawingml/2006/main">
+              <a:ext uri="{FF2B5EF4-FFF2-40B4-BE49-F238E27FC236}">
+                <a16:creationId xmlns:a16="http://schemas.microsoft.com/office/drawing/2014/main" id="{B6C0CA1F-57B1-474B-9B82-BC22D5EC674D}"/>
+              </a:ext>
+            </a:extLst>
+          </p:cNvPr>
+          <p:cNvSpPr>
+            <a:spLocks xmlns:a="http://schemas.openxmlformats.org/drawingml/2006/main" noGrp="1"/>
+          </p:cNvSpPr>
+          <p:nvPr/>
+        </p:nvSpPr>
+        <p:spPr>
+          <a:xfrm xmlns:a="http://schemas.openxmlformats.org/drawingml/2006/main">
+            <a:off x="1197864" y="4343400"/>
+            <a:ext cx="9784080" cy="822960"/>
           </a:xfrm>
           <a:prstGeom xmlns:a="http://schemas.openxmlformats.org/drawingml/2006/main" prst="rect">
             <a:avLst/>
@@ -7508,149 +7508,8 @@
                 <a:ea typeface="Poppins"/>
                 <a:cs typeface="Poppins"/>
               </a:rPr>
-              <a:t>PSNR 27.0756 -&gt; 27.7637
-SSIM 0.70638 -&gt; 0.73490
-LPIPS 0.36586 -&gt; 0.32771</a:t>
-            </a:r>
-            <a:endParaRPr sz="1200"/>
-          </a:p>
-        </p:txBody>
-      </p:sp>
-      <p:sp>
-        <p:nvSpPr>
-          <p:cNvPr id="20" name="Shape 14">
-            <a:extLst xmlns:a="http://schemas.openxmlformats.org/drawingml/2006/main">
-              <a:ext uri="{FF2B5EF4-FFF2-40B4-BE49-F238E27FC236}">
-                <a16:creationId xmlns:a16="http://schemas.microsoft.com/office/drawing/2014/main" id="{A5515EF3-1027-4657-B6B7-C43C9F385264}"/>
-              </a:ext>
-            </a:extLst>
-          </p:cNvPr>
-          <p:cNvSpPr>
-            <a:spLocks xmlns:a="http://schemas.openxmlformats.org/drawingml/2006/main" noGrp="1"/>
-          </p:cNvSpPr>
-          <p:nvPr/>
-        </p:nvSpPr>
-        <p:spPr>
-          <a:xfrm xmlns:a="http://schemas.openxmlformats.org/drawingml/2006/main">
-            <a:off x="6210605" y="3845052"/>
-            <a:ext cx="5020056" cy="1429207"/>
-          </a:xfrm>
-          <a:prstGeom xmlns:a="http://schemas.openxmlformats.org/drawingml/2006/main" prst="roundRect">
-            <a:avLst>
-              <a:gd name="adj" fmla="val 3412"/>
-            </a:avLst>
-          </a:prstGeom>
-          <a:solidFill xmlns:a="http://schemas.openxmlformats.org/drawingml/2006/main">
-            <a:srgbClr val="1E3A8A">
-              <a:alpha val="40000"/>
-            </a:srgbClr>
-          </a:solidFill>
-          <a:ln xmlns:a="http://schemas.openxmlformats.org/drawingml/2006/main" w="12700">
-            <a:solidFill>
-              <a:srgbClr val="1D4ED8"/>
-            </a:solidFill>
-            <a:prstDash val="solid"/>
-          </a:ln>
-        </p:spPr>
-        <p:txBody>
-          <a:bodyPr xmlns:a="http://schemas.openxmlformats.org/drawingml/2006/main"/>
-          <a:lstStyle xmlns:a="http://schemas.openxmlformats.org/drawingml/2006/main"/>
-          <a:p xmlns:a="http://schemas.openxmlformats.org/drawingml/2006/main">
-            <a:endParaRPr/>
-          </a:p>
-        </p:txBody>
-      </p:sp>
-      <p:sp>
-        <p:nvSpPr>
-          <p:cNvPr id="21" name="Text 15">
-            <a:extLst xmlns:a="http://schemas.openxmlformats.org/drawingml/2006/main">
-              <a:ext uri="{FF2B5EF4-FFF2-40B4-BE49-F238E27FC236}">
-                <a16:creationId xmlns:a16="http://schemas.microsoft.com/office/drawing/2014/main" id="{73B7CA59-9D34-409C-B85B-2D1D05628FFC}"/>
-              </a:ext>
-            </a:extLst>
-          </p:cNvPr>
-          <p:cNvSpPr>
-            <a:spLocks xmlns:a="http://schemas.openxmlformats.org/drawingml/2006/main" noGrp="1"/>
-          </p:cNvSpPr>
-          <p:nvPr/>
-        </p:nvSpPr>
-        <p:spPr>
-          <a:xfrm xmlns:a="http://schemas.openxmlformats.org/drawingml/2006/main">
-            <a:off x="6448349" y="4082796"/>
-            <a:ext cx="1901038" cy="191110"/>
-          </a:xfrm>
-          <a:prstGeom xmlns:a="http://schemas.openxmlformats.org/drawingml/2006/main" prst="rect">
-            <a:avLst/>
-          </a:prstGeom>
-          <a:noFill xmlns:a="http://schemas.openxmlformats.org/drawingml/2006/main"/>
-        </p:spPr>
-        <p:txBody>
-          <a:bodyPr xmlns:a="http://schemas.openxmlformats.org/drawingml/2006/main" wrap="square" lIns="0" tIns="0" rIns="0" bIns="0" anchor="ctr"/>
-          <a:lstStyle xmlns:a="http://schemas.openxmlformats.org/drawingml/2006/main"/>
-          <a:p xmlns:a="http://schemas.openxmlformats.org/drawingml/2006/main">
-            <a:pPr marL="0" indent="0" algn="l">
-              <a:buNone/>
-            </a:pPr>
-            <a:r>
-              <a:rPr sz="1000" b="1">
-                <a:solidFill>
-                  <a:srgbClr val="9CA3AF"/>
-                </a:solidFill>
-                <a:latin typeface="Poppins"/>
-                <a:ea typeface="Poppins"/>
-                <a:cs typeface="Poppins"/>
-              </a:rPr>
-              <a:t>FINAL MODEL</a:t>
-            </a:r>
-            <a:endParaRPr sz="1000"/>
-          </a:p>
-        </p:txBody>
-      </p:sp>
-      <p:sp>
-        <p:nvSpPr>
-          <p:cNvPr id="22" name="Text 16">
-            <a:extLst xmlns:a="http://schemas.openxmlformats.org/drawingml/2006/main">
-              <a:ext uri="{FF2B5EF4-FFF2-40B4-BE49-F238E27FC236}">
-                <a16:creationId xmlns:a16="http://schemas.microsoft.com/office/drawing/2014/main" id="{B6C0CA1F-57B1-474B-9B82-BC22D5EC674D}"/>
-              </a:ext>
-            </a:extLst>
-          </p:cNvPr>
-          <p:cNvSpPr>
-            <a:spLocks xmlns:a="http://schemas.openxmlformats.org/drawingml/2006/main" noGrp="1"/>
-          </p:cNvSpPr>
-          <p:nvPr/>
-        </p:nvSpPr>
-        <p:spPr>
-          <a:xfrm xmlns:a="http://schemas.openxmlformats.org/drawingml/2006/main">
-            <a:off x="6448349" y="4349801"/>
-            <a:ext cx="4239158" cy="676656"/>
-          </a:xfrm>
-          <a:prstGeom xmlns:a="http://schemas.openxmlformats.org/drawingml/2006/main" prst="rect">
-            <a:avLst/>
-          </a:prstGeom>
-          <a:noFill xmlns:a="http://schemas.openxmlformats.org/drawingml/2006/main"/>
-        </p:spPr>
-        <p:txBody>
-          <a:bodyPr xmlns:a="http://schemas.openxmlformats.org/drawingml/2006/main" wrap="square" lIns="0" tIns="0" rIns="0" bIns="0" anchor="ctr"/>
-          <a:lstStyle xmlns:a="http://schemas.openxmlformats.org/drawingml/2006/main"/>
-          <a:p xmlns:a="http://schemas.openxmlformats.org/drawingml/2006/main">
-            <a:pPr marL="0" indent="0" algn="l">
-              <a:buNone/>
-            </a:pPr>
-            <a:r>
-              <a:rPr sz="1200" i="1">
-                <a:solidFill>
-                  <a:srgbClr val="FFFFFF">
-                    <a:alpha val="70000"/>
-                  </a:srgbClr>
-                </a:solidFill>
-                <a:latin typeface="Poppins"/>
-                <a:ea typeface="Poppins"/>
-                <a:cs typeface="Poppins"/>
-              </a:rPr>
-              <a:t>6,939,289 parameters | 27.9 MB
-29.35 ms model | 38.42 ms end-to-end
-+6.111 dB PSNR over bicubic</a:t>
+              <a:t>29.10 dB PSNR | 0.7784 SSIM | 0.2760 LPIPS | 0.9396 MS-SSIM  (+6.111 dB over bicubic)
+6,939,289 parameters | 27.9 MB | 29.35 ms model | 38.42 ms end-to-end</a:t>
             </a:r>
             <a:endParaRPr sz="1200"/>
           </a:p>
@@ -9860,1218 +9719,6 @@
 </file>
 
 <file path=ppt/slides/slide8.xml><?xml version="1.0" encoding="utf-8"?>
-<p:sld xmlns:p="http://schemas.openxmlformats.org/presentationml/2006/main">
-  <p:cSld>
-    <p:spTree>
-      <p:nvGrpSpPr>
-        <p:cNvPr id="1" name=""/>
-        <p:cNvGrpSpPr/>
-        <p:nvPr/>
-      </p:nvGrpSpPr>
-      <p:grpSpPr>
-        <a:xfrm xmlns:a="http://schemas.openxmlformats.org/drawingml/2006/main"/>
-      </p:grpSpPr>
-      <p:sp>
-        <p:nvSpPr>
-          <p:cNvPr id="2" name="Shape 0">
-            <a:extLst xmlns:a="http://schemas.openxmlformats.org/drawingml/2006/main">
-              <a:ext uri="{FF2B5EF4-FFF2-40B4-BE49-F238E27FC236}">
-                <a16:creationId xmlns:a16="http://schemas.microsoft.com/office/drawing/2014/main" id="{C9037111-F71A-4C77-A879-EC3C27A6684B}"/>
-              </a:ext>
-            </a:extLst>
-          </p:cNvPr>
-          <p:cNvSpPr>
-            <a:spLocks xmlns:a="http://schemas.openxmlformats.org/drawingml/2006/main" noGrp="1"/>
-          </p:cNvSpPr>
-          <p:nvPr/>
-        </p:nvSpPr>
-        <p:spPr>
-          <a:xfrm xmlns:a="http://schemas.openxmlformats.org/drawingml/2006/main">
-            <a:off x="0" y="0"/>
-            <a:ext cx="12191695" cy="6858000"/>
-          </a:xfrm>
-          <a:prstGeom xmlns:a="http://schemas.openxmlformats.org/drawingml/2006/main" prst="rect">
-            <a:avLst/>
-          </a:prstGeom>
-          <a:solidFill xmlns:a="http://schemas.openxmlformats.org/drawingml/2006/main">
-            <a:srgbClr val="000036"/>
-          </a:solidFill>
-        </p:spPr>
-        <p:txBody>
-          <a:bodyPr xmlns:a="http://schemas.openxmlformats.org/drawingml/2006/main"/>
-          <a:lstStyle xmlns:a="http://schemas.openxmlformats.org/drawingml/2006/main"/>
-          <a:p xmlns:a="http://schemas.openxmlformats.org/drawingml/2006/main">
-            <a:endParaRPr/>
-          </a:p>
-        </p:txBody>
-      </p:sp>
-      <p:pic>
-        <p:nvPicPr>
-          <p:cNvPr id="41" name="Image 0"/>
-          <p:cNvPicPr>
-            <a:picLocks xmlns:a="http://schemas.openxmlformats.org/drawingml/2006/main" noChangeAspect="1"/>
-          </p:cNvPicPr>
-          <p:nvPr/>
-        </p:nvPicPr>
-        <p:blipFill>
-          <a:blip xmlns:r="http://schemas.openxmlformats.org/officeDocument/2006/relationships" xmlns:a="http://schemas.openxmlformats.org/drawingml/2006/main" r:embed="R1bff38b57a55401f">
-            <a:alphaModFix amt="10000"/>
-          </a:blip>
-          <a:srcRect xmlns:a="http://schemas.openxmlformats.org/drawingml/2006/main" l="12327" t="0" r="12327" b="0"/>
-          <a:stretch xmlns:a="http://schemas.openxmlformats.org/drawingml/2006/main"/>
-        </p:blipFill>
-        <p:spPr>
-          <a:xfrm xmlns:a="http://schemas.openxmlformats.org/drawingml/2006/main">
-            <a:off x="0" y="0"/>
-            <a:ext cx="12191695" cy="6858000"/>
-          </a:xfrm>
-          <a:prstGeom xmlns:a="http://schemas.openxmlformats.org/drawingml/2006/main" prst="rect">
-            <a:avLst/>
-          </a:prstGeom>
-        </p:spPr>
-      </p:pic>
-      <p:sp>
-        <p:nvSpPr>
-          <p:cNvPr id="4" name="Shape 1">
-            <a:extLst xmlns:a="http://schemas.openxmlformats.org/drawingml/2006/main">
-              <a:ext uri="{FF2B5EF4-FFF2-40B4-BE49-F238E27FC236}">
-                <a16:creationId xmlns:a16="http://schemas.microsoft.com/office/drawing/2014/main" id="{278EC71B-5FE1-4A7C-A640-5D651CF82027}"/>
-              </a:ext>
-            </a:extLst>
-          </p:cNvPr>
-          <p:cNvSpPr>
-            <a:spLocks xmlns:a="http://schemas.openxmlformats.org/drawingml/2006/main" noGrp="1"/>
-          </p:cNvSpPr>
-          <p:nvPr/>
-        </p:nvSpPr>
-        <p:spPr>
-          <a:xfrm xmlns:a="http://schemas.openxmlformats.org/drawingml/2006/main">
-            <a:off x="571500" y="286207"/>
-            <a:ext cx="11048695" cy="666598"/>
-          </a:xfrm>
-          <a:prstGeom xmlns:a="http://schemas.openxmlformats.org/drawingml/2006/main" prst="roundRect">
-            <a:avLst>
-              <a:gd name="adj" fmla="val 15677"/>
-            </a:avLst>
-          </a:prstGeom>
-          <a:solidFill xmlns:a="http://schemas.openxmlformats.org/drawingml/2006/main">
-            <a:srgbClr val="FFFFFF">
-              <a:alpha val="95000"/>
-            </a:srgbClr>
-          </a:solidFill>
-          <a:effectLst xmlns:a="http://schemas.openxmlformats.org/drawingml/2006/main">
-            <a:outerShdw blurRad="63500" dist="38100" dir="5400000" algn="bl" rotWithShape="0">
-              <a:srgbClr val="000000">
-                <a:alpha val="10000"/>
-              </a:srgbClr>
-            </a:outerShdw>
-          </a:effectLst>
-        </p:spPr>
-        <p:txBody>
-          <a:bodyPr xmlns:a="http://schemas.openxmlformats.org/drawingml/2006/main"/>
-          <a:lstStyle xmlns:a="http://schemas.openxmlformats.org/drawingml/2006/main"/>
-          <a:p xmlns:a="http://schemas.openxmlformats.org/drawingml/2006/main">
-            <a:endParaRPr/>
-          </a:p>
-        </p:txBody>
-      </p:sp>
-      <p:pic>
-        <p:nvPicPr>
-          <p:cNvPr id="43" name="Image 1"/>
-          <p:cNvPicPr>
-            <a:picLocks xmlns:a="http://schemas.openxmlformats.org/drawingml/2006/main" noChangeAspect="1"/>
-          </p:cNvPicPr>
-          <p:nvPr/>
-        </p:nvPicPr>
-        <p:blipFill>
-          <a:blip xmlns:r="http://schemas.openxmlformats.org/officeDocument/2006/relationships" xmlns:a="http://schemas.openxmlformats.org/drawingml/2006/main" r:embed="R43f2fcf545a74ddd"/>
-          <a:srcRect xmlns:a="http://schemas.openxmlformats.org/drawingml/2006/main" l="0" t="10" r="0" b="10"/>
-          <a:stretch xmlns:a="http://schemas.openxmlformats.org/drawingml/2006/main"/>
-        </p:blipFill>
-        <p:spPr>
-          <a:xfrm xmlns:a="http://schemas.openxmlformats.org/drawingml/2006/main">
-            <a:off x="857707" y="381305"/>
-            <a:ext cx="1266444" cy="476402"/>
-          </a:xfrm>
-          <a:prstGeom xmlns:a="http://schemas.openxmlformats.org/drawingml/2006/main" prst="rect">
-            <a:avLst/>
-          </a:prstGeom>
-        </p:spPr>
-      </p:pic>
-      <p:pic>
-        <p:nvPicPr>
-          <p:cNvPr id="44" name="Image 2"/>
-          <p:cNvPicPr>
-            <a:picLocks xmlns:a="http://schemas.openxmlformats.org/drawingml/2006/main" noChangeAspect="1"/>
-          </p:cNvPicPr>
-          <p:nvPr/>
-        </p:nvPicPr>
-        <p:blipFill>
-          <a:blip xmlns:r="http://schemas.openxmlformats.org/officeDocument/2006/relationships" xmlns:a="http://schemas.openxmlformats.org/drawingml/2006/main" r:embed="R41def692a7c347ee"/>
-          <a:srcRect xmlns:a="http://schemas.openxmlformats.org/drawingml/2006/main" l="0" t="0" r="0" b="0"/>
-          <a:stretch xmlns:a="http://schemas.openxmlformats.org/drawingml/2006/main"/>
-        </p:blipFill>
-        <p:spPr>
-          <a:xfrm xmlns:a="http://schemas.openxmlformats.org/drawingml/2006/main">
-            <a:off x="10858500" y="381305"/>
-            <a:ext cx="476402" cy="476402"/>
-          </a:xfrm>
-          <a:prstGeom xmlns:a="http://schemas.openxmlformats.org/drawingml/2006/main" prst="rect">
-            <a:avLst/>
-          </a:prstGeom>
-        </p:spPr>
-      </p:pic>
-      <p:sp>
-        <p:nvSpPr>
-          <p:cNvPr id="7" name="Shape 2">
-            <a:extLst xmlns:a="http://schemas.openxmlformats.org/drawingml/2006/main">
-              <a:ext uri="{FF2B5EF4-FFF2-40B4-BE49-F238E27FC236}">
-                <a16:creationId xmlns:a16="http://schemas.microsoft.com/office/drawing/2014/main" id="{7EBA136F-A561-41DF-85B8-BFDE7D906FB8}"/>
-              </a:ext>
-            </a:extLst>
-          </p:cNvPr>
-          <p:cNvSpPr>
-            <a:spLocks xmlns:a="http://schemas.openxmlformats.org/drawingml/2006/main" noGrp="1"/>
-          </p:cNvSpPr>
-          <p:nvPr/>
-        </p:nvSpPr>
-        <p:spPr>
-          <a:xfrm xmlns:a="http://schemas.openxmlformats.org/drawingml/2006/main">
-            <a:off x="571500" y="1190549"/>
-            <a:ext cx="75895" cy="409651"/>
-          </a:xfrm>
-          <a:prstGeom xmlns:a="http://schemas.openxmlformats.org/drawingml/2006/main" prst="rect">
-            <a:avLst/>
-          </a:prstGeom>
-          <a:solidFill xmlns:a="http://schemas.openxmlformats.org/drawingml/2006/main">
-            <a:srgbClr val="88E555"/>
-          </a:solidFill>
-        </p:spPr>
-        <p:txBody>
-          <a:bodyPr xmlns:a="http://schemas.openxmlformats.org/drawingml/2006/main"/>
-          <a:lstStyle xmlns:a="http://schemas.openxmlformats.org/drawingml/2006/main"/>
-          <a:p xmlns:a="http://schemas.openxmlformats.org/drawingml/2006/main">
-            <a:endParaRPr/>
-          </a:p>
-        </p:txBody>
-      </p:sp>
-      <p:sp>
-        <p:nvSpPr>
-          <p:cNvPr id="8" name="Text 3">
-            <a:extLst xmlns:a="http://schemas.openxmlformats.org/drawingml/2006/main">
-              <a:ext uri="{FF2B5EF4-FFF2-40B4-BE49-F238E27FC236}">
-                <a16:creationId xmlns:a16="http://schemas.microsoft.com/office/drawing/2014/main" id="{C85F60AA-A842-4CFB-A946-6744286FBCFB}"/>
-              </a:ext>
-            </a:extLst>
-          </p:cNvPr>
-          <p:cNvSpPr>
-            <a:spLocks xmlns:a="http://schemas.openxmlformats.org/drawingml/2006/main" noGrp="1"/>
-          </p:cNvSpPr>
-          <p:nvPr/>
-        </p:nvSpPr>
-        <p:spPr>
-          <a:xfrm xmlns:a="http://schemas.openxmlformats.org/drawingml/2006/main">
-            <a:off x="838505" y="1152144"/>
-            <a:ext cx="4624121" cy="467258"/>
-          </a:xfrm>
-          <a:prstGeom xmlns:a="http://schemas.openxmlformats.org/drawingml/2006/main" prst="rect">
-            <a:avLst/>
-          </a:prstGeom>
-          <a:noFill xmlns:a="http://schemas.openxmlformats.org/drawingml/2006/main"/>
-        </p:spPr>
-        <p:txBody>
-          <a:bodyPr xmlns:a="http://schemas.openxmlformats.org/drawingml/2006/main" wrap="square" lIns="0" tIns="0" rIns="0" bIns="0" anchor="ctr"/>
-          <a:lstStyle xmlns:a="http://schemas.openxmlformats.org/drawingml/2006/main"/>
-          <a:p xmlns:a="http://schemas.openxmlformats.org/drawingml/2006/main">
-            <a:pPr marL="0" indent="0" algn="l">
-              <a:buNone/>
-            </a:pPr>
-            <a:r>
-              <a:rPr sz="2600" b="1">
-                <a:solidFill>
-                  <a:srgbClr val="FFFFFF"/>
-                </a:solidFill>
-                <a:latin typeface="Poppins"/>
-                <a:ea typeface="Poppins"/>
-                <a:cs typeface="Poppins"/>
-              </a:rPr>
-              <a:t>Research, Code and References</a:t>
-            </a:r>
-            <a:endParaRPr sz="2600"/>
-          </a:p>
-        </p:txBody>
-      </p:sp>
-      <p:sp>
-        <p:nvSpPr>
-          <p:cNvPr id="9" name="Shape 4">
-            <a:extLst xmlns:a="http://schemas.openxmlformats.org/drawingml/2006/main">
-              <a:ext uri="{FF2B5EF4-FFF2-40B4-BE49-F238E27FC236}">
-                <a16:creationId xmlns:a16="http://schemas.microsoft.com/office/drawing/2014/main" id="{82CCE1F5-2E64-4213-B2CE-19F7C5B80504}"/>
-              </a:ext>
-            </a:extLst>
-          </p:cNvPr>
-          <p:cNvSpPr>
-            <a:spLocks xmlns:a="http://schemas.openxmlformats.org/drawingml/2006/main" noGrp="1"/>
-          </p:cNvSpPr>
-          <p:nvPr/>
-        </p:nvSpPr>
-        <p:spPr>
-          <a:xfrm xmlns:a="http://schemas.openxmlformats.org/drawingml/2006/main">
-            <a:off x="571500" y="1830629"/>
-            <a:ext cx="11048695" cy="4743907"/>
-          </a:xfrm>
-          <a:prstGeom xmlns:a="http://schemas.openxmlformats.org/drawingml/2006/main" prst="roundRect">
-            <a:avLst>
-              <a:gd name="adj" fmla="val 619"/>
-            </a:avLst>
-          </a:prstGeom>
-          <a:solidFill xmlns:a="http://schemas.openxmlformats.org/drawingml/2006/main">
-            <a:srgbClr val="FFFFFF">
-              <a:alpha val="5000"/>
-            </a:srgbClr>
-          </a:solidFill>
-          <a:ln xmlns:a="http://schemas.openxmlformats.org/drawingml/2006/main" w="12700">
-            <a:solidFill>
-              <a:srgbClr val="88E555">
-                <a:alpha val="30000"/>
-              </a:srgbClr>
-            </a:solidFill>
-            <a:prstDash val="solid"/>
-          </a:ln>
-        </p:spPr>
-        <p:txBody>
-          <a:bodyPr xmlns:a="http://schemas.openxmlformats.org/drawingml/2006/main"/>
-          <a:lstStyle xmlns:a="http://schemas.openxmlformats.org/drawingml/2006/main"/>
-          <a:p xmlns:a="http://schemas.openxmlformats.org/drawingml/2006/main">
-            <a:endParaRPr/>
-          </a:p>
-        </p:txBody>
-      </p:sp>
-      <p:sp>
-        <p:nvSpPr>
-          <p:cNvPr id="10" name="Shape 5">
-            <a:extLst xmlns:a="http://schemas.openxmlformats.org/drawingml/2006/main">
-              <a:ext uri="{FF2B5EF4-FFF2-40B4-BE49-F238E27FC236}">
-                <a16:creationId xmlns:a16="http://schemas.microsoft.com/office/drawing/2014/main" id="{3825CC24-1991-4317-89CA-9C93F0CD54DA}"/>
-              </a:ext>
-            </a:extLst>
-          </p:cNvPr>
-          <p:cNvSpPr>
-            <a:spLocks xmlns:a="http://schemas.openxmlformats.org/drawingml/2006/main" noGrp="1"/>
-          </p:cNvSpPr>
-          <p:nvPr/>
-        </p:nvSpPr>
-        <p:spPr>
-          <a:xfrm xmlns:a="http://schemas.openxmlformats.org/drawingml/2006/main">
-            <a:off x="571500" y="1830629"/>
-            <a:ext cx="190195" cy="190195"/>
-          </a:xfrm>
-          <a:prstGeom xmlns:a="http://schemas.openxmlformats.org/drawingml/2006/main" prst="roundRect">
-            <a:avLst>
-              <a:gd name="adj" fmla="val 192308"/>
-            </a:avLst>
-          </a:prstGeom>
-          <a:noFill xmlns:a="http://schemas.openxmlformats.org/drawingml/2006/main"/>
-          <a:ln xmlns:a="http://schemas.openxmlformats.org/drawingml/2006/main" w="38100">
-            <a:solidFill>
-              <a:srgbClr val="88E555"/>
-            </a:solidFill>
-            <a:prstDash val="solid"/>
-          </a:ln>
-        </p:spPr>
-        <p:txBody>
-          <a:bodyPr xmlns:a="http://schemas.openxmlformats.org/drawingml/2006/main"/>
-          <a:lstStyle xmlns:a="http://schemas.openxmlformats.org/drawingml/2006/main"/>
-          <a:p xmlns:a="http://schemas.openxmlformats.org/drawingml/2006/main">
-            <a:endParaRPr/>
-          </a:p>
-        </p:txBody>
-      </p:sp>
-      <p:sp>
-        <p:nvSpPr>
-          <p:cNvPr id="11" name="Shape 6">
-            <a:extLst xmlns:a="http://schemas.openxmlformats.org/drawingml/2006/main">
-              <a:ext uri="{FF2B5EF4-FFF2-40B4-BE49-F238E27FC236}">
-                <a16:creationId xmlns:a16="http://schemas.microsoft.com/office/drawing/2014/main" id="{28BE731D-AC61-41AE-B8FB-85ED6386DB32}"/>
-              </a:ext>
-            </a:extLst>
-          </p:cNvPr>
-          <p:cNvSpPr>
-            <a:spLocks xmlns:a="http://schemas.openxmlformats.org/drawingml/2006/main" noGrp="1"/>
-          </p:cNvSpPr>
-          <p:nvPr/>
-        </p:nvSpPr>
-        <p:spPr>
-          <a:xfrm xmlns:a="http://schemas.openxmlformats.org/drawingml/2006/main">
-            <a:off x="11430000" y="1830629"/>
-            <a:ext cx="190195" cy="190195"/>
-          </a:xfrm>
-          <a:prstGeom xmlns:a="http://schemas.openxmlformats.org/drawingml/2006/main" prst="rect">
-            <a:avLst/>
-          </a:prstGeom>
-          <a:noFill xmlns:a="http://schemas.openxmlformats.org/drawingml/2006/main"/>
-          <a:ln xmlns:a="http://schemas.openxmlformats.org/drawingml/2006/main" w="38100">
-            <a:solidFill>
-              <a:srgbClr val="88E555"/>
-            </a:solidFill>
-            <a:prstDash val="solid"/>
-          </a:ln>
-        </p:spPr>
-        <p:txBody>
-          <a:bodyPr xmlns:a="http://schemas.openxmlformats.org/drawingml/2006/main"/>
-          <a:lstStyle xmlns:a="http://schemas.openxmlformats.org/drawingml/2006/main"/>
-          <a:p xmlns:a="http://schemas.openxmlformats.org/drawingml/2006/main">
-            <a:endParaRPr/>
-          </a:p>
-        </p:txBody>
-      </p:sp>
-      <p:sp>
-        <p:nvSpPr>
-          <p:cNvPr id="12" name="Shape 7">
-            <a:extLst xmlns:a="http://schemas.openxmlformats.org/drawingml/2006/main">
-              <a:ext uri="{FF2B5EF4-FFF2-40B4-BE49-F238E27FC236}">
-                <a16:creationId xmlns:a16="http://schemas.microsoft.com/office/drawing/2014/main" id="{44E0D3B1-CF7A-4253-8535-98420E9B0299}"/>
-              </a:ext>
-            </a:extLst>
-          </p:cNvPr>
-          <p:cNvSpPr>
-            <a:spLocks xmlns:a="http://schemas.openxmlformats.org/drawingml/2006/main" noGrp="1"/>
-          </p:cNvSpPr>
-          <p:nvPr/>
-        </p:nvSpPr>
-        <p:spPr>
-          <a:xfrm xmlns:a="http://schemas.openxmlformats.org/drawingml/2006/main">
-            <a:off x="571500" y="6381598"/>
-            <a:ext cx="190195" cy="190195"/>
-          </a:xfrm>
-          <a:prstGeom xmlns:a="http://schemas.openxmlformats.org/drawingml/2006/main" prst="rect">
-            <a:avLst/>
-          </a:prstGeom>
-          <a:noFill xmlns:a="http://schemas.openxmlformats.org/drawingml/2006/main"/>
-          <a:ln xmlns:a="http://schemas.openxmlformats.org/drawingml/2006/main" w="38100">
-            <a:solidFill>
-              <a:srgbClr val="88E555"/>
-            </a:solidFill>
-            <a:prstDash val="solid"/>
-          </a:ln>
-        </p:spPr>
-        <p:txBody>
-          <a:bodyPr xmlns:a="http://schemas.openxmlformats.org/drawingml/2006/main"/>
-          <a:lstStyle xmlns:a="http://schemas.openxmlformats.org/drawingml/2006/main"/>
-          <a:p xmlns:a="http://schemas.openxmlformats.org/drawingml/2006/main">
-            <a:endParaRPr/>
-          </a:p>
-        </p:txBody>
-      </p:sp>
-      <p:sp>
-        <p:nvSpPr>
-          <p:cNvPr id="13" name="Shape 8">
-            <a:extLst xmlns:a="http://schemas.openxmlformats.org/drawingml/2006/main">
-              <a:ext uri="{FF2B5EF4-FFF2-40B4-BE49-F238E27FC236}">
-                <a16:creationId xmlns:a16="http://schemas.microsoft.com/office/drawing/2014/main" id="{D69008A7-0E40-45A2-9E4B-7333E4370058}"/>
-              </a:ext>
-            </a:extLst>
-          </p:cNvPr>
-          <p:cNvSpPr>
-            <a:spLocks xmlns:a="http://schemas.openxmlformats.org/drawingml/2006/main" noGrp="1"/>
-          </p:cNvSpPr>
-          <p:nvPr/>
-        </p:nvSpPr>
-        <p:spPr>
-          <a:xfrm xmlns:a="http://schemas.openxmlformats.org/drawingml/2006/main">
-            <a:off x="11430000" y="6381598"/>
-            <a:ext cx="190195" cy="190195"/>
-          </a:xfrm>
-          <a:prstGeom xmlns:a="http://schemas.openxmlformats.org/drawingml/2006/main" prst="rect">
-            <a:avLst/>
-          </a:prstGeom>
-          <a:noFill xmlns:a="http://schemas.openxmlformats.org/drawingml/2006/main"/>
-          <a:ln xmlns:a="http://schemas.openxmlformats.org/drawingml/2006/main" w="38100">
-            <a:solidFill>
-              <a:srgbClr val="88E555"/>
-            </a:solidFill>
-            <a:prstDash val="solid"/>
-          </a:ln>
-        </p:spPr>
-        <p:txBody>
-          <a:bodyPr xmlns:a="http://schemas.openxmlformats.org/drawingml/2006/main"/>
-          <a:lstStyle xmlns:a="http://schemas.openxmlformats.org/drawingml/2006/main"/>
-          <a:p xmlns:a="http://schemas.openxmlformats.org/drawingml/2006/main">
-            <a:endParaRPr/>
-          </a:p>
-        </p:txBody>
-      </p:sp>
-      <p:sp>
-        <p:nvSpPr>
-          <p:cNvPr id="14" name="Shape 9">
-            <a:extLst xmlns:a="http://schemas.openxmlformats.org/drawingml/2006/main">
-              <a:ext uri="{FF2B5EF4-FFF2-40B4-BE49-F238E27FC236}">
-                <a16:creationId xmlns:a16="http://schemas.microsoft.com/office/drawing/2014/main" id="{95375588-F903-4DB8-B067-2FA74878F769}"/>
-              </a:ext>
-            </a:extLst>
-          </p:cNvPr>
-          <p:cNvSpPr>
-            <a:spLocks xmlns:a="http://schemas.openxmlformats.org/drawingml/2006/main" noGrp="1"/>
-          </p:cNvSpPr>
-          <p:nvPr/>
-        </p:nvSpPr>
-        <p:spPr>
-          <a:xfrm xmlns:a="http://schemas.openxmlformats.org/drawingml/2006/main">
-            <a:off x="961949" y="2173529"/>
-            <a:ext cx="476402" cy="476402"/>
-          </a:xfrm>
-          <a:prstGeom xmlns:a="http://schemas.openxmlformats.org/drawingml/2006/main" prst="ellipse">
-            <a:avLst/>
-          </a:prstGeom>
-          <a:solidFill xmlns:a="http://schemas.openxmlformats.org/drawingml/2006/main">
-            <a:srgbClr val="273383">
-              <a:alpha val="50000"/>
-            </a:srgbClr>
-          </a:solidFill>
-          <a:ln xmlns:a="http://schemas.openxmlformats.org/drawingml/2006/main" w="25400">
-            <a:solidFill>
-              <a:srgbClr val="AEFF82"/>
-            </a:solidFill>
-            <a:prstDash val="solid"/>
-          </a:ln>
-        </p:spPr>
-        <p:txBody>
-          <a:bodyPr xmlns:a="http://schemas.openxmlformats.org/drawingml/2006/main"/>
-          <a:lstStyle xmlns:a="http://schemas.openxmlformats.org/drawingml/2006/main"/>
-          <a:p xmlns:a="http://schemas.openxmlformats.org/drawingml/2006/main">
-            <a:endParaRPr/>
-          </a:p>
-        </p:txBody>
-      </p:sp>
-      <p:pic>
-        <p:nvPicPr>
-          <p:cNvPr id="53" name="Image 3"/>
-          <p:cNvPicPr>
-            <a:picLocks xmlns:a="http://schemas.openxmlformats.org/drawingml/2006/main" noChangeAspect="1"/>
-          </p:cNvPicPr>
-          <p:nvPr/>
-        </p:nvPicPr>
-        <p:blipFill>
-          <a:blip xmlns:r="http://schemas.openxmlformats.org/officeDocument/2006/relationships" xmlns:a="http://schemas.openxmlformats.org/drawingml/2006/main" r:embed="R808b02de48434bc3"/>
-          <a:srcRect xmlns:a="http://schemas.openxmlformats.org/drawingml/2006/main" l="0" t="0" r="0" b="0"/>
-          <a:stretch xmlns:a="http://schemas.openxmlformats.org/drawingml/2006/main"/>
-        </p:blipFill>
-        <p:spPr>
-          <a:xfrm xmlns:a="http://schemas.openxmlformats.org/drawingml/2006/main">
-            <a:off x="1086307" y="2297887"/>
-            <a:ext cx="228600" cy="228600"/>
-          </a:xfrm>
-          <a:prstGeom xmlns:a="http://schemas.openxmlformats.org/drawingml/2006/main" prst="rect">
-            <a:avLst/>
-          </a:prstGeom>
-        </p:spPr>
-      </p:pic>
-      <p:sp>
-        <p:nvSpPr>
-          <p:cNvPr id="16" name="Text 10">
-            <a:extLst xmlns:a="http://schemas.openxmlformats.org/drawingml/2006/main">
-              <a:ext uri="{FF2B5EF4-FFF2-40B4-BE49-F238E27FC236}">
-                <a16:creationId xmlns:a16="http://schemas.microsoft.com/office/drawing/2014/main" id="{AE7389F1-75D7-49FE-BC3F-1962A1D15DE1}"/>
-              </a:ext>
-            </a:extLst>
-          </p:cNvPr>
-          <p:cNvSpPr>
-            <a:spLocks xmlns:a="http://schemas.openxmlformats.org/drawingml/2006/main" noGrp="1"/>
-          </p:cNvSpPr>
-          <p:nvPr/>
-        </p:nvSpPr>
-        <p:spPr>
-          <a:xfrm xmlns:a="http://schemas.openxmlformats.org/drawingml/2006/main">
-            <a:off x="1628546" y="2173529"/>
-            <a:ext cx="3810305" cy="267005"/>
-          </a:xfrm>
-          <a:prstGeom xmlns:a="http://schemas.openxmlformats.org/drawingml/2006/main" prst="rect">
-            <a:avLst/>
-          </a:prstGeom>
-          <a:noFill xmlns:a="http://schemas.openxmlformats.org/drawingml/2006/main"/>
-        </p:spPr>
-        <p:txBody>
-          <a:bodyPr xmlns:a="http://schemas.openxmlformats.org/drawingml/2006/main" wrap="square" lIns="0" tIns="0" rIns="0" bIns="0" anchor="ctr"/>
-          <a:lstStyle xmlns:a="http://schemas.openxmlformats.org/drawingml/2006/main"/>
-          <a:p xmlns:a="http://schemas.openxmlformats.org/drawingml/2006/main">
-            <a:pPr marL="0" indent="0" algn="l">
-              <a:buNone/>
-            </a:pPr>
-            <a:r>
-              <a:rPr sz="1500" b="1">
-                <a:solidFill>
-                  <a:srgbClr val="88E555"/>
-                </a:solidFill>
-                <a:latin typeface="Poppins"/>
-                <a:ea typeface="Poppins"/>
-                <a:cs typeface="Poppins"/>
-              </a:rPr>
-              <a:t>Research Basis + Reproducibility</a:t>
-            </a:r>
-            <a:endParaRPr sz="1500"/>
-          </a:p>
-        </p:txBody>
-      </p:sp>
-      <p:sp>
-        <p:nvSpPr>
-          <p:cNvPr id="17" name="Text 11">
-            <a:extLst xmlns:a="http://schemas.openxmlformats.org/drawingml/2006/main">
-              <a:ext uri="{FF2B5EF4-FFF2-40B4-BE49-F238E27FC236}">
-                <a16:creationId xmlns:a16="http://schemas.microsoft.com/office/drawing/2014/main" id="{FEF4022D-E493-4C00-8470-A4FCC3516AE1}"/>
-              </a:ext>
-            </a:extLst>
-          </p:cNvPr>
-          <p:cNvSpPr>
-            <a:spLocks xmlns:a="http://schemas.openxmlformats.org/drawingml/2006/main" noGrp="1"/>
-          </p:cNvSpPr>
-          <p:nvPr/>
-        </p:nvSpPr>
-        <p:spPr>
-          <a:xfrm xmlns:a="http://schemas.openxmlformats.org/drawingml/2006/main">
-            <a:off x="1628546" y="2516429"/>
-            <a:ext cx="5701284" cy="191110"/>
-          </a:xfrm>
-          <a:prstGeom xmlns:a="http://schemas.openxmlformats.org/drawingml/2006/main" prst="rect">
-            <a:avLst/>
-          </a:prstGeom>
-          <a:noFill xmlns:a="http://schemas.openxmlformats.org/drawingml/2006/main"/>
-        </p:spPr>
-        <p:txBody>
-          <a:bodyPr xmlns:a="http://schemas.openxmlformats.org/drawingml/2006/main" wrap="square" lIns="0" tIns="0" rIns="0" bIns="0" anchor="ctr"/>
-          <a:lstStyle xmlns:a="http://schemas.openxmlformats.org/drawingml/2006/main"/>
-          <a:p xmlns:a="http://schemas.openxmlformats.org/drawingml/2006/main">
-            <a:pPr marL="0" indent="0" algn="l">
-              <a:buNone/>
-            </a:pPr>
-            <a:r>
-              <a:rPr sz="1000">
-                <a:solidFill>
-                  <a:srgbClr val="D1D5DB"/>
-                </a:solidFill>
-                <a:latin typeface="Poppins"/>
-                <a:ea typeface="Poppins"/>
-                <a:cs typeface="Poppins"/>
-              </a:rPr>
-              <a:t>Implemented evidence and submission links</a:t>
-            </a:r>
-            <a:endParaRPr sz="1000"/>
-          </a:p>
-        </p:txBody>
-      </p:sp>
-      <p:sp>
-        <p:nvSpPr>
-          <p:cNvPr id="18" name="Shape 12">
-            <a:extLst xmlns:a="http://schemas.openxmlformats.org/drawingml/2006/main">
-              <a:ext uri="{FF2B5EF4-FFF2-40B4-BE49-F238E27FC236}">
-                <a16:creationId xmlns:a16="http://schemas.microsoft.com/office/drawing/2014/main" id="{7379F5BC-BB2E-49A8-8A77-C43AD7E0D550}"/>
-              </a:ext>
-            </a:extLst>
-          </p:cNvPr>
-          <p:cNvSpPr>
-            <a:spLocks xmlns:a="http://schemas.openxmlformats.org/drawingml/2006/main" noGrp="1"/>
-          </p:cNvSpPr>
-          <p:nvPr/>
-        </p:nvSpPr>
-        <p:spPr>
-          <a:xfrm xmlns:a="http://schemas.openxmlformats.org/drawingml/2006/main">
-            <a:off x="1628546" y="2783434"/>
-            <a:ext cx="9601200" cy="1067105"/>
-          </a:xfrm>
-          <a:prstGeom xmlns:a="http://schemas.openxmlformats.org/drawingml/2006/main" prst="roundRect">
-            <a:avLst>
-              <a:gd name="adj" fmla="val 6121"/>
-            </a:avLst>
-          </a:prstGeom>
-          <a:solidFill xmlns:a="http://schemas.openxmlformats.org/drawingml/2006/main">
-            <a:srgbClr val="1E3A8A">
-              <a:alpha val="40000"/>
-            </a:srgbClr>
-          </a:solidFill>
-          <a:ln xmlns:a="http://schemas.openxmlformats.org/drawingml/2006/main" w="12700">
-            <a:solidFill>
-              <a:srgbClr val="1D4ED8"/>
-            </a:solidFill>
-            <a:prstDash val="solid"/>
-          </a:ln>
-        </p:spPr>
-        <p:txBody>
-          <a:bodyPr xmlns:a="http://schemas.openxmlformats.org/drawingml/2006/main"/>
-          <a:lstStyle xmlns:a="http://schemas.openxmlformats.org/drawingml/2006/main"/>
-          <a:p xmlns:a="http://schemas.openxmlformats.org/drawingml/2006/main">
-            <a:endParaRPr/>
-          </a:p>
-        </p:txBody>
-      </p:sp>
-      <p:sp>
-        <p:nvSpPr>
-          <p:cNvPr id="19" name="Text 13">
-            <a:extLst xmlns:a="http://schemas.openxmlformats.org/drawingml/2006/main">
-              <a:ext uri="{FF2B5EF4-FFF2-40B4-BE49-F238E27FC236}">
-                <a16:creationId xmlns:a16="http://schemas.microsoft.com/office/drawing/2014/main" id="{3B5C7BFA-93F7-4CBE-B016-734BAF9860A5}"/>
-              </a:ext>
-            </a:extLst>
-          </p:cNvPr>
-          <p:cNvSpPr>
-            <a:spLocks xmlns:a="http://schemas.openxmlformats.org/drawingml/2006/main" noGrp="1"/>
-          </p:cNvSpPr>
-          <p:nvPr/>
-        </p:nvSpPr>
-        <p:spPr>
-          <a:xfrm xmlns:a="http://schemas.openxmlformats.org/drawingml/2006/main">
-            <a:off x="1790395" y="2945282"/>
-            <a:ext cx="5544007" cy="219456"/>
-          </a:xfrm>
-          <a:prstGeom xmlns:a="http://schemas.openxmlformats.org/drawingml/2006/main" prst="rect">
-            <a:avLst/>
-          </a:prstGeom>
-          <a:noFill xmlns:a="http://schemas.openxmlformats.org/drawingml/2006/main"/>
-        </p:spPr>
-        <p:txBody>
-          <a:bodyPr xmlns:a="http://schemas.openxmlformats.org/drawingml/2006/main" wrap="square" lIns="0" tIns="0" rIns="0" bIns="0" anchor="ctr"/>
-          <a:lstStyle xmlns:a="http://schemas.openxmlformats.org/drawingml/2006/main"/>
-          <a:p xmlns:a="http://schemas.openxmlformats.org/drawingml/2006/main">
-            <a:pPr marL="0" indent="0" algn="l">
-              <a:buNone/>
-            </a:pPr>
-            <a:r>
-              <a:rPr sz="1200" i="1">
-                <a:solidFill>
-                  <a:srgbClr val="FFFFFF">
-                    <a:alpha val="70000"/>
-                  </a:srgbClr>
-                </a:solidFill>
-                <a:latin typeface="Poppins"/>
-                <a:ea typeface="Poppins"/>
-                <a:cs typeface="Poppins"/>
-              </a:rPr>
-              <a:t>2026 UCAN and ShiftLUT motivate wider spatial context; our 5x5 depthwise ablation is the measured adaptation.
-GitHub: github.com/Vikaash301/kla-semicon   Video: [ADD OPTIONAL DEMO URL]</a:t>
-            </a:r>
-            <a:endParaRPr sz="1200"/>
-          </a:p>
-        </p:txBody>
-      </p:sp>
-      <p:sp>
-        <p:nvSpPr>
-          <p:cNvPr id="20" name="Shape 14">
-            <a:extLst xmlns:a="http://schemas.openxmlformats.org/drawingml/2006/main">
-              <a:ext uri="{FF2B5EF4-FFF2-40B4-BE49-F238E27FC236}">
-                <a16:creationId xmlns:a16="http://schemas.microsoft.com/office/drawing/2014/main" id="{B1DCBEC9-7DB7-4767-A007-6A2DA0389783}"/>
-              </a:ext>
-            </a:extLst>
-          </p:cNvPr>
-          <p:cNvSpPr>
-            <a:spLocks xmlns:a="http://schemas.openxmlformats.org/drawingml/2006/main" noGrp="1"/>
-          </p:cNvSpPr>
-          <p:nvPr/>
-        </p:nvSpPr>
-        <p:spPr>
-          <a:xfrm xmlns:a="http://schemas.openxmlformats.org/drawingml/2006/main">
-            <a:off x="961949" y="4155034"/>
-            <a:ext cx="476402" cy="476402"/>
-          </a:xfrm>
-          <a:prstGeom xmlns:a="http://schemas.openxmlformats.org/drawingml/2006/main" prst="ellipse">
-            <a:avLst/>
-          </a:prstGeom>
-          <a:solidFill xmlns:a="http://schemas.openxmlformats.org/drawingml/2006/main">
-            <a:srgbClr val="273383">
-              <a:alpha val="50000"/>
-            </a:srgbClr>
-          </a:solidFill>
-          <a:ln xmlns:a="http://schemas.openxmlformats.org/drawingml/2006/main" w="25400">
-            <a:solidFill>
-              <a:srgbClr val="AEFF82"/>
-            </a:solidFill>
-            <a:prstDash val="solid"/>
-          </a:ln>
-        </p:spPr>
-        <p:txBody>
-          <a:bodyPr xmlns:a="http://schemas.openxmlformats.org/drawingml/2006/main"/>
-          <a:lstStyle xmlns:a="http://schemas.openxmlformats.org/drawingml/2006/main"/>
-          <a:p xmlns:a="http://schemas.openxmlformats.org/drawingml/2006/main">
-            <a:endParaRPr/>
-          </a:p>
-        </p:txBody>
-      </p:sp>
-      <p:pic>
-        <p:nvPicPr>
-          <p:cNvPr id="59" name="Image 4"/>
-          <p:cNvPicPr>
-            <a:picLocks xmlns:a="http://schemas.openxmlformats.org/drawingml/2006/main" noChangeAspect="1"/>
-          </p:cNvPicPr>
-          <p:nvPr/>
-        </p:nvPicPr>
-        <p:blipFill>
-          <a:blip xmlns:r="http://schemas.openxmlformats.org/officeDocument/2006/relationships" xmlns:a="http://schemas.openxmlformats.org/drawingml/2006/main" r:embed="Reed5ab06475047d1"/>
-          <a:srcRect xmlns:a="http://schemas.openxmlformats.org/drawingml/2006/main" l="-80" t="0" r="-80" b="0"/>
-          <a:stretch xmlns:a="http://schemas.openxmlformats.org/drawingml/2006/main"/>
-        </p:blipFill>
-        <p:spPr>
-          <a:xfrm xmlns:a="http://schemas.openxmlformats.org/drawingml/2006/main">
-            <a:off x="1057046" y="4279392"/>
-            <a:ext cx="286207" cy="228600"/>
-          </a:xfrm>
-          <a:prstGeom xmlns:a="http://schemas.openxmlformats.org/drawingml/2006/main" prst="rect">
-            <a:avLst/>
-          </a:prstGeom>
-        </p:spPr>
-      </p:pic>
-      <p:sp>
-        <p:nvSpPr>
-          <p:cNvPr id="22" name="Text 15">
-            <a:extLst xmlns:a="http://schemas.openxmlformats.org/drawingml/2006/main">
-              <a:ext uri="{FF2B5EF4-FFF2-40B4-BE49-F238E27FC236}">
-                <a16:creationId xmlns:a16="http://schemas.microsoft.com/office/drawing/2014/main" id="{6BFB0B10-EC6D-4447-8EEE-561D39E0F166}"/>
-              </a:ext>
-            </a:extLst>
-          </p:cNvPr>
-          <p:cNvSpPr>
-            <a:spLocks xmlns:a="http://schemas.openxmlformats.org/drawingml/2006/main" noGrp="1"/>
-          </p:cNvSpPr>
-          <p:nvPr/>
-        </p:nvSpPr>
-        <p:spPr>
-          <a:xfrm xmlns:a="http://schemas.openxmlformats.org/drawingml/2006/main">
-            <a:off x="1628546" y="4155034"/>
-            <a:ext cx="2343607" cy="267005"/>
-          </a:xfrm>
-          <a:prstGeom xmlns:a="http://schemas.openxmlformats.org/drawingml/2006/main" prst="rect">
-            <a:avLst/>
-          </a:prstGeom>
-          <a:noFill xmlns:a="http://schemas.openxmlformats.org/drawingml/2006/main"/>
-        </p:spPr>
-        <p:txBody>
-          <a:bodyPr xmlns:a="http://schemas.openxmlformats.org/drawingml/2006/main" wrap="square" lIns="0" tIns="0" rIns="0" bIns="0" anchor="ctr"/>
-          <a:lstStyle xmlns:a="http://schemas.openxmlformats.org/drawingml/2006/main"/>
-          <a:p xmlns:a="http://schemas.openxmlformats.org/drawingml/2006/main">
-            <a:pPr marL="0" indent="0" algn="l">
-              <a:buNone/>
-            </a:pPr>
-            <a:r>
-              <a:rPr sz="1500" b="1">
-                <a:solidFill>
-                  <a:srgbClr val="88E555"/>
-                </a:solidFill>
-                <a:latin typeface="Poppins"/>
-                <a:ea typeface="Poppins"/>
-                <a:cs typeface="Poppins"/>
-              </a:rPr>
-              <a:t>References &amp; Citations</a:t>
-            </a:r>
-            <a:endParaRPr sz="1500"/>
-          </a:p>
-        </p:txBody>
-      </p:sp>
-      <p:sp>
-        <p:nvSpPr>
-          <p:cNvPr id="23" name="Text 16">
-            <a:extLst xmlns:a="http://schemas.openxmlformats.org/drawingml/2006/main">
-              <a:ext uri="{FF2B5EF4-FFF2-40B4-BE49-F238E27FC236}">
-                <a16:creationId xmlns:a16="http://schemas.microsoft.com/office/drawing/2014/main" id="{86363100-0497-428A-81EA-F4FF828D7BA9}"/>
-              </a:ext>
-            </a:extLst>
-          </p:cNvPr>
-          <p:cNvSpPr>
-            <a:spLocks xmlns:a="http://schemas.openxmlformats.org/drawingml/2006/main" noGrp="1"/>
-          </p:cNvSpPr>
-          <p:nvPr/>
-        </p:nvSpPr>
-        <p:spPr>
-          <a:xfrm xmlns:a="http://schemas.openxmlformats.org/drawingml/2006/main">
-            <a:off x="1628546" y="4497934"/>
-            <a:ext cx="2767889" cy="191110"/>
-          </a:xfrm>
-          <a:prstGeom xmlns:a="http://schemas.openxmlformats.org/drawingml/2006/main" prst="rect">
-            <a:avLst/>
-          </a:prstGeom>
-          <a:noFill xmlns:a="http://schemas.openxmlformats.org/drawingml/2006/main"/>
-        </p:spPr>
-        <p:txBody>
-          <a:bodyPr xmlns:a="http://schemas.openxmlformats.org/drawingml/2006/main" wrap="square" lIns="0" tIns="0" rIns="0" bIns="0" anchor="ctr"/>
-          <a:lstStyle xmlns:a="http://schemas.openxmlformats.org/drawingml/2006/main"/>
-          <a:p xmlns:a="http://schemas.openxmlformats.org/drawingml/2006/main">
-            <a:pPr marL="0" indent="0" algn="l">
-              <a:buNone/>
-            </a:pPr>
-            <a:r>
-              <a:rPr sz="1000">
-                <a:solidFill>
-                  <a:srgbClr val="D1D5DB"/>
-                </a:solidFill>
-                <a:latin typeface="Poppins"/>
-                <a:ea typeface="Poppins"/>
-                <a:cs typeface="Poppins"/>
-              </a:rPr>
-              <a:t>Primary sources; full verified list in REFERENCES.md</a:t>
-            </a:r>
-            <a:endParaRPr sz="1000"/>
-          </a:p>
-        </p:txBody>
-      </p:sp>
-      <p:sp>
-        <p:nvSpPr>
-          <p:cNvPr id="24" name="Shape 17">
-            <a:extLst xmlns:a="http://schemas.openxmlformats.org/drawingml/2006/main">
-              <a:ext uri="{FF2B5EF4-FFF2-40B4-BE49-F238E27FC236}">
-                <a16:creationId xmlns:a16="http://schemas.microsoft.com/office/drawing/2014/main" id="{73305CAA-8728-4677-8131-61C32640DAD2}"/>
-              </a:ext>
-            </a:extLst>
-          </p:cNvPr>
-          <p:cNvSpPr>
-            <a:spLocks xmlns:a="http://schemas.openxmlformats.org/drawingml/2006/main" noGrp="1"/>
-          </p:cNvSpPr>
-          <p:nvPr/>
-        </p:nvSpPr>
-        <p:spPr>
-          <a:xfrm xmlns:a="http://schemas.openxmlformats.org/drawingml/2006/main">
-            <a:off x="1628546" y="4764938"/>
-            <a:ext cx="9601200" cy="1410005"/>
-          </a:xfrm>
-          <a:prstGeom xmlns:a="http://schemas.openxmlformats.org/drawingml/2006/main" prst="roundRect">
-            <a:avLst>
-              <a:gd name="adj" fmla="val 3505"/>
-            </a:avLst>
-          </a:prstGeom>
-          <a:solidFill xmlns:a="http://schemas.openxmlformats.org/drawingml/2006/main">
-            <a:srgbClr val="1E3A8A">
-              <a:alpha val="40000"/>
-            </a:srgbClr>
-          </a:solidFill>
-          <a:ln xmlns:a="http://schemas.openxmlformats.org/drawingml/2006/main" w="12700">
-            <a:solidFill>
-              <a:srgbClr val="1D4ED8"/>
-            </a:solidFill>
-            <a:prstDash val="solid"/>
-          </a:ln>
-        </p:spPr>
-        <p:txBody>
-          <a:bodyPr xmlns:a="http://schemas.openxmlformats.org/drawingml/2006/main"/>
-          <a:lstStyle xmlns:a="http://schemas.openxmlformats.org/drawingml/2006/main"/>
-          <a:p xmlns:a="http://schemas.openxmlformats.org/drawingml/2006/main">
-            <a:endParaRPr/>
-          </a:p>
-        </p:txBody>
-      </p:sp>
-      <p:sp>
-        <p:nvSpPr>
-          <p:cNvPr id="25" name="Shape 18">
-            <a:extLst xmlns:a="http://schemas.openxmlformats.org/drawingml/2006/main">
-              <a:ext uri="{FF2B5EF4-FFF2-40B4-BE49-F238E27FC236}">
-                <a16:creationId xmlns:a16="http://schemas.microsoft.com/office/drawing/2014/main" id="{3DB6E72D-8F93-4D68-BCAE-C9578A37177F}"/>
-              </a:ext>
-            </a:extLst>
-          </p:cNvPr>
-          <p:cNvSpPr>
-            <a:spLocks xmlns:a="http://schemas.openxmlformats.org/drawingml/2006/main" noGrp="1"/>
-          </p:cNvSpPr>
-          <p:nvPr/>
-        </p:nvSpPr>
-        <p:spPr>
-          <a:xfrm xmlns:a="http://schemas.openxmlformats.org/drawingml/2006/main">
-            <a:off x="1790395" y="5232197"/>
-            <a:ext cx="9277502" cy="9144"/>
-          </a:xfrm>
-          <a:prstGeom xmlns:a="http://schemas.openxmlformats.org/drawingml/2006/main" prst="rect">
-            <a:avLst/>
-          </a:prstGeom>
-          <a:solidFill xmlns:a="http://schemas.openxmlformats.org/drawingml/2006/main">
-            <a:srgbClr val="1E40AF">
-              <a:alpha val="30000"/>
-            </a:srgbClr>
-          </a:solidFill>
-        </p:spPr>
-        <p:txBody>
-          <a:bodyPr xmlns:a="http://schemas.openxmlformats.org/drawingml/2006/main"/>
-          <a:lstStyle xmlns:a="http://schemas.openxmlformats.org/drawingml/2006/main"/>
-          <a:p xmlns:a="http://schemas.openxmlformats.org/drawingml/2006/main">
-            <a:endParaRPr/>
-          </a:p>
-        </p:txBody>
-      </p:sp>
-      <p:sp>
-        <p:nvSpPr>
-          <p:cNvPr id="26" name="Text 19">
-            <a:extLst xmlns:a="http://schemas.openxmlformats.org/drawingml/2006/main">
-              <a:ext uri="{FF2B5EF4-FFF2-40B4-BE49-F238E27FC236}">
-                <a16:creationId xmlns:a16="http://schemas.microsoft.com/office/drawing/2014/main" id="{DDD962C3-A587-4204-AF8E-66B06E9C3BCD}"/>
-              </a:ext>
-            </a:extLst>
-          </p:cNvPr>
-          <p:cNvSpPr>
-            <a:spLocks xmlns:a="http://schemas.openxmlformats.org/drawingml/2006/main" noGrp="1"/>
-          </p:cNvSpPr>
-          <p:nvPr/>
-        </p:nvSpPr>
-        <p:spPr>
-          <a:xfrm xmlns:a="http://schemas.openxmlformats.org/drawingml/2006/main">
-            <a:off x="1790395" y="4926787"/>
-            <a:ext cx="3219602" cy="228600"/>
-          </a:xfrm>
-          <a:prstGeom xmlns:a="http://schemas.openxmlformats.org/drawingml/2006/main" prst="rect">
-            <a:avLst/>
-          </a:prstGeom>
-          <a:noFill xmlns:a="http://schemas.openxmlformats.org/drawingml/2006/main"/>
-        </p:spPr>
-        <p:txBody>
-          <a:bodyPr xmlns:a="http://schemas.openxmlformats.org/drawingml/2006/main" wrap="square" lIns="0" tIns="0" rIns="0" bIns="0" anchor="ctr"/>
-          <a:lstStyle xmlns:a="http://schemas.openxmlformats.org/drawingml/2006/main"/>
-          <a:p xmlns:a="http://schemas.openxmlformats.org/drawingml/2006/main">
-            <a:pPr marL="0" indent="0" algn="l">
-              <a:buNone/>
-            </a:pPr>
-            <a:r>
-              <a:rPr sz="1200">
-                <a:solidFill>
-                  <a:srgbClr val="FFFFFF">
-                    <a:alpha val="80000"/>
-                  </a:srgbClr>
-                </a:solidFill>
-                <a:latin typeface="Poppins"/>
-                <a:ea typeface="Poppins"/>
-                <a:cs typeface="Poppins"/>
-              </a:rPr>
-              <a:t>UCAN - Expansive Receptive Fields for Lightweight SR (CVPR 2026)</a:t>
-            </a:r>
-            <a:endParaRPr sz="1200"/>
-          </a:p>
-        </p:txBody>
-      </p:sp>
-      <p:sp>
-        <p:nvSpPr>
-          <p:cNvPr id="27" name="Shape 20">
-            <a:extLst xmlns:a="http://schemas.openxmlformats.org/drawingml/2006/main">
-              <a:ext uri="{FF2B5EF4-FFF2-40B4-BE49-F238E27FC236}">
-                <a16:creationId xmlns:a16="http://schemas.microsoft.com/office/drawing/2014/main" id="{D35B5B60-6271-4DAA-96D1-CC2DB3FF2B62}"/>
-              </a:ext>
-            </a:extLst>
-          </p:cNvPr>
-          <p:cNvSpPr>
-            <a:spLocks xmlns:a="http://schemas.openxmlformats.org/drawingml/2006/main" noGrp="1"/>
-          </p:cNvSpPr>
-          <p:nvPr/>
-        </p:nvSpPr>
-        <p:spPr>
-          <a:xfrm xmlns:a="http://schemas.openxmlformats.org/drawingml/2006/main">
-            <a:off x="1790395" y="5661050"/>
-            <a:ext cx="9277502" cy="9144"/>
-          </a:xfrm>
-          <a:prstGeom xmlns:a="http://schemas.openxmlformats.org/drawingml/2006/main" prst="rect">
-            <a:avLst/>
-          </a:prstGeom>
-          <a:solidFill xmlns:a="http://schemas.openxmlformats.org/drawingml/2006/main">
-            <a:srgbClr val="1E40AF">
-              <a:alpha val="30000"/>
-            </a:srgbClr>
-          </a:solidFill>
-        </p:spPr>
-        <p:txBody>
-          <a:bodyPr xmlns:a="http://schemas.openxmlformats.org/drawingml/2006/main"/>
-          <a:lstStyle xmlns:a="http://schemas.openxmlformats.org/drawingml/2006/main"/>
-          <a:p xmlns:a="http://schemas.openxmlformats.org/drawingml/2006/main">
-            <a:endParaRPr/>
-          </a:p>
-        </p:txBody>
-      </p:sp>
-      <p:sp>
-        <p:nvSpPr>
-          <p:cNvPr id="28" name="Text 21">
-            <a:extLst xmlns:a="http://schemas.openxmlformats.org/drawingml/2006/main">
-              <a:ext uri="{FF2B5EF4-FFF2-40B4-BE49-F238E27FC236}">
-                <a16:creationId xmlns:a16="http://schemas.microsoft.com/office/drawing/2014/main" id="{5F98A61B-0AA1-4CB1-B67A-4A38EFA7430D}"/>
-              </a:ext>
-            </a:extLst>
-          </p:cNvPr>
-          <p:cNvSpPr>
-            <a:spLocks xmlns:a="http://schemas.openxmlformats.org/drawingml/2006/main" noGrp="1"/>
-          </p:cNvSpPr>
-          <p:nvPr/>
-        </p:nvSpPr>
-        <p:spPr>
-          <a:xfrm xmlns:a="http://schemas.openxmlformats.org/drawingml/2006/main">
-            <a:off x="1790395" y="5355641"/>
-            <a:ext cx="3258007" cy="228600"/>
-          </a:xfrm>
-          <a:prstGeom xmlns:a="http://schemas.openxmlformats.org/drawingml/2006/main" prst="rect">
-            <a:avLst/>
-          </a:prstGeom>
-          <a:noFill xmlns:a="http://schemas.openxmlformats.org/drawingml/2006/main"/>
-        </p:spPr>
-        <p:txBody>
-          <a:bodyPr xmlns:a="http://schemas.openxmlformats.org/drawingml/2006/main" wrap="square" lIns="0" tIns="0" rIns="0" bIns="0" anchor="ctr"/>
-          <a:lstStyle xmlns:a="http://schemas.openxmlformats.org/drawingml/2006/main"/>
-          <a:p xmlns:a="http://schemas.openxmlformats.org/drawingml/2006/main">
-            <a:pPr marL="0" indent="0" algn="l">
-              <a:buNone/>
-            </a:pPr>
-            <a:r>
-              <a:rPr sz="1200">
-                <a:solidFill>
-                  <a:srgbClr val="FFFFFF">
-                    <a:alpha val="80000"/>
-                  </a:srgbClr>
-                </a:solidFill>
-                <a:latin typeface="Poppins"/>
-                <a:ea typeface="Poppins"/>
-                <a:cs typeface="Poppins"/>
-              </a:rPr>
-              <a:t>ShiftLUT - Spatial Shift Enhanced LUTs for Restoration (CVPR 2026)</a:t>
-            </a:r>
-            <a:endParaRPr sz="1200"/>
-          </a:p>
-        </p:txBody>
-      </p:sp>
-      <p:sp>
-        <p:nvSpPr>
-          <p:cNvPr id="29" name="Text 22">
-            <a:extLst xmlns:a="http://schemas.openxmlformats.org/drawingml/2006/main">
-              <a:ext uri="{FF2B5EF4-FFF2-40B4-BE49-F238E27FC236}">
-                <a16:creationId xmlns:a16="http://schemas.microsoft.com/office/drawing/2014/main" id="{5A7ADD0F-A618-47A5-BF65-348B65B28668}"/>
-              </a:ext>
-            </a:extLst>
-          </p:cNvPr>
-          <p:cNvSpPr>
-            <a:spLocks xmlns:a="http://schemas.openxmlformats.org/drawingml/2006/main" noGrp="1"/>
-          </p:cNvSpPr>
-          <p:nvPr/>
-        </p:nvSpPr>
-        <p:spPr>
-          <a:xfrm xmlns:a="http://schemas.openxmlformats.org/drawingml/2006/main">
-            <a:off x="1790395" y="5783580"/>
-            <a:ext cx="3258007" cy="228600"/>
-          </a:xfrm>
-          <a:prstGeom xmlns:a="http://schemas.openxmlformats.org/drawingml/2006/main" prst="rect">
-            <a:avLst/>
-          </a:prstGeom>
-          <a:noFill xmlns:a="http://schemas.openxmlformats.org/drawingml/2006/main"/>
-        </p:spPr>
-        <p:txBody>
-          <a:bodyPr xmlns:a="http://schemas.openxmlformats.org/drawingml/2006/main" wrap="square" lIns="0" tIns="0" rIns="0" bIns="0" anchor="ctr"/>
-          <a:lstStyle xmlns:a="http://schemas.openxmlformats.org/drawingml/2006/main"/>
-          <a:p xmlns:a="http://schemas.openxmlformats.org/drawingml/2006/main">
-            <a:pPr marL="0" indent="0" algn="l">
-              <a:buNone/>
-            </a:pPr>
-            <a:r>
-              <a:rPr sz="1200">
-                <a:solidFill>
-                  <a:srgbClr val="FFFFFF">
-                    <a:alpha val="80000"/>
-                  </a:srgbClr>
-                </a:solidFill>
-                <a:latin typeface="Poppins"/>
-                <a:ea typeface="Poppins"/>
-                <a:cs typeface="Poppins"/>
-              </a:rPr>
-              <a:t>I4C Hackathon 2026 challenge and released paired dataset (i4c.in)</a:t>
-            </a:r>
-            <a:endParaRPr sz="1200"/>
-          </a:p>
-        </p:txBody>
-      </p:sp>
-      <p:pic>
-        <p:nvPicPr>
-          <p:cNvPr id="68" name="Picture 29"/>
-          <p:cNvPicPr>
-            <a:picLocks xmlns:a="http://schemas.openxmlformats.org/drawingml/2006/main" noChangeAspect="1"/>
-          </p:cNvPicPr>
-          <p:nvPr/>
-        </p:nvPicPr>
-        <p:blipFill>
-          <a:blip xmlns:r="http://schemas.openxmlformats.org/officeDocument/2006/relationships" xmlns:a="http://schemas.openxmlformats.org/drawingml/2006/main" r:embed="R5e1489bab4ce4354"/>
-          <a:stretch xmlns:a="http://schemas.openxmlformats.org/drawingml/2006/main">
-            <a:fillRect l="0" t="0" r="0" b="0"/>
-          </a:stretch>
-        </p:blipFill>
-        <p:spPr>
-          <a:xfrm xmlns:a="http://schemas.openxmlformats.org/drawingml/2006/main">
-            <a:off x="5292164" y="227710"/>
-            <a:ext cx="1607366" cy="783591"/>
-          </a:xfrm>
-          <a:prstGeom xmlns:a="http://schemas.openxmlformats.org/drawingml/2006/main" prst="rect">
-            <a:avLst/>
-          </a:prstGeom>
-        </p:spPr>
-      </p:pic>
-      <p:sp>
-        <p:nvSpPr>
-          <p:cNvPr id="32" name="Shape 1">
-            <a:extLst xmlns:a="http://schemas.openxmlformats.org/drawingml/2006/main">
-              <a:ext uri="{FF2B5EF4-FFF2-40B4-BE49-F238E27FC236}">
-                <a16:creationId xmlns:a16="http://schemas.microsoft.com/office/drawing/2014/main" id="{3E27E131-AC1D-E75C-0267-02565ACC1BC3}"/>
-              </a:ext>
-            </a:extLst>
-          </p:cNvPr>
-          <p:cNvSpPr>
-            <a:spLocks xmlns:a="http://schemas.openxmlformats.org/drawingml/2006/main" noGrp="1"/>
-          </p:cNvSpPr>
-          <p:nvPr/>
-        </p:nvSpPr>
-        <p:spPr>
-          <a:xfrm xmlns:a="http://schemas.openxmlformats.org/drawingml/2006/main">
-            <a:off x="571500" y="259714"/>
-            <a:ext cx="11048695" cy="857707"/>
-          </a:xfrm>
-          <a:prstGeom xmlns:a="http://schemas.openxmlformats.org/drawingml/2006/main" prst="roundRect">
-            <a:avLst>
-              <a:gd name="adj" fmla="val 9476"/>
-            </a:avLst>
-          </a:prstGeom>
-          <a:solidFill xmlns:a="http://schemas.openxmlformats.org/drawingml/2006/main">
-            <a:srgbClr val="FFFFFF">
-              <a:alpha val="95000"/>
-            </a:srgbClr>
-          </a:solidFill>
-          <a:effectLst xmlns:a="http://schemas.openxmlformats.org/drawingml/2006/main">
-            <a:outerShdw blurRad="63500" dist="38100" dir="5400000" algn="bl" rotWithShape="0">
-              <a:srgbClr val="000000">
-                <a:alpha val="10000"/>
-              </a:srgbClr>
-            </a:outerShdw>
-          </a:effectLst>
-        </p:spPr>
-        <p:txBody>
-          <a:bodyPr xmlns:a="http://schemas.openxmlformats.org/drawingml/2006/main"/>
-          <a:lstStyle xmlns:a="http://schemas.openxmlformats.org/drawingml/2006/main"/>
-          <a:p xmlns:a="http://schemas.openxmlformats.org/drawingml/2006/main">
-            <a:endParaRPr/>
-          </a:p>
-        </p:txBody>
-      </p:sp>
-      <p:pic>
-        <p:nvPicPr>
-          <p:cNvPr id="70" name="Picture 32"/>
-          <p:cNvPicPr>
-            <a:picLocks xmlns:a="http://schemas.openxmlformats.org/drawingml/2006/main" noChangeAspect="1"/>
-          </p:cNvPicPr>
-          <p:nvPr/>
-        </p:nvPicPr>
-        <p:blipFill>
-          <a:blip xmlns:r="http://schemas.openxmlformats.org/officeDocument/2006/relationships" xmlns:a="http://schemas.openxmlformats.org/drawingml/2006/main" r:embed="R02a4233f212a4117"/>
-          <a:stretch xmlns:a="http://schemas.openxmlformats.org/drawingml/2006/main">
-            <a:fillRect l="0" t="0" r="0" b="0"/>
-          </a:stretch>
-        </p:blipFill>
-        <p:spPr>
-          <a:xfrm xmlns:a="http://schemas.openxmlformats.org/drawingml/2006/main">
-            <a:off x="1514101" y="390016"/>
-            <a:ext cx="9163491" cy="586435"/>
-          </a:xfrm>
-          <a:prstGeom xmlns:a="http://schemas.openxmlformats.org/drawingml/2006/main" prst="rect">
-            <a:avLst/>
-          </a:prstGeom>
-        </p:spPr>
-      </p:pic>
-    </p:spTree>
-    <p:extLst>
-      <p:ext uri="{BB962C8B-B14F-4D97-AF65-F5344CB8AC3E}">
-        <p14:creationId xmlns:p14="http://schemas.microsoft.com/office/powerpoint/2010/main" val="1067614550"/>
-      </p:ext>
-    </p:extLst>
-  </p:cSld>
-</p:sld>
-</file>
-
-<file path=ppt/slides/slide9.xml><?xml version="1.0" encoding="utf-8"?>
 <p:sld xmlns:a="http://schemas.openxmlformats.org/drawingml/2006/main" xmlns:p="http://schemas.openxmlformats.org/presentationml/2006/main" xmlns:r="http://schemas.openxmlformats.org/officeDocument/2006/relationships">
   <p:cSld>
     <p:spTree>
@@ -11860,6 +10507,1218 @@
   <p:clrMapOvr>
     <a:masterClrMapping/>
   </p:clrMapOvr>
+</p:sld>
+</file>
+
+<file path=ppt/slides/slide9.xml><?xml version="1.0" encoding="utf-8"?>
+<p:sld xmlns:p="http://schemas.openxmlformats.org/presentationml/2006/main">
+  <p:cSld>
+    <p:spTree>
+      <p:nvGrpSpPr>
+        <p:cNvPr id="1" name=""/>
+        <p:cNvGrpSpPr/>
+        <p:nvPr/>
+      </p:nvGrpSpPr>
+      <p:grpSpPr>
+        <a:xfrm xmlns:a="http://schemas.openxmlformats.org/drawingml/2006/main"/>
+      </p:grpSpPr>
+      <p:sp>
+        <p:nvSpPr>
+          <p:cNvPr id="2" name="Shape 0">
+            <a:extLst xmlns:a="http://schemas.openxmlformats.org/drawingml/2006/main">
+              <a:ext uri="{FF2B5EF4-FFF2-40B4-BE49-F238E27FC236}">
+                <a16:creationId xmlns:a16="http://schemas.microsoft.com/office/drawing/2014/main" id="{C9037111-F71A-4C77-A879-EC3C27A6684B}"/>
+              </a:ext>
+            </a:extLst>
+          </p:cNvPr>
+          <p:cNvSpPr>
+            <a:spLocks xmlns:a="http://schemas.openxmlformats.org/drawingml/2006/main" noGrp="1"/>
+          </p:cNvSpPr>
+          <p:nvPr/>
+        </p:nvSpPr>
+        <p:spPr>
+          <a:xfrm xmlns:a="http://schemas.openxmlformats.org/drawingml/2006/main">
+            <a:off x="0" y="0"/>
+            <a:ext cx="12191695" cy="6858000"/>
+          </a:xfrm>
+          <a:prstGeom xmlns:a="http://schemas.openxmlformats.org/drawingml/2006/main" prst="rect">
+            <a:avLst/>
+          </a:prstGeom>
+          <a:solidFill xmlns:a="http://schemas.openxmlformats.org/drawingml/2006/main">
+            <a:srgbClr val="000036"/>
+          </a:solidFill>
+        </p:spPr>
+        <p:txBody>
+          <a:bodyPr xmlns:a="http://schemas.openxmlformats.org/drawingml/2006/main"/>
+          <a:lstStyle xmlns:a="http://schemas.openxmlformats.org/drawingml/2006/main"/>
+          <a:p xmlns:a="http://schemas.openxmlformats.org/drawingml/2006/main">
+            <a:endParaRPr/>
+          </a:p>
+        </p:txBody>
+      </p:sp>
+      <p:pic>
+        <p:nvPicPr>
+          <p:cNvPr id="41" name="Image 0"/>
+          <p:cNvPicPr>
+            <a:picLocks xmlns:a="http://schemas.openxmlformats.org/drawingml/2006/main" noChangeAspect="1"/>
+          </p:cNvPicPr>
+          <p:nvPr/>
+        </p:nvPicPr>
+        <p:blipFill>
+          <a:blip xmlns:r="http://schemas.openxmlformats.org/officeDocument/2006/relationships" xmlns:a="http://schemas.openxmlformats.org/drawingml/2006/main" r:embed="R1bff38b57a55401f">
+            <a:alphaModFix amt="10000"/>
+          </a:blip>
+          <a:srcRect xmlns:a="http://schemas.openxmlformats.org/drawingml/2006/main" l="12327" t="0" r="12327" b="0"/>
+          <a:stretch xmlns:a="http://schemas.openxmlformats.org/drawingml/2006/main"/>
+        </p:blipFill>
+        <p:spPr>
+          <a:xfrm xmlns:a="http://schemas.openxmlformats.org/drawingml/2006/main">
+            <a:off x="0" y="0"/>
+            <a:ext cx="12191695" cy="6858000"/>
+          </a:xfrm>
+          <a:prstGeom xmlns:a="http://schemas.openxmlformats.org/drawingml/2006/main" prst="rect">
+            <a:avLst/>
+          </a:prstGeom>
+        </p:spPr>
+      </p:pic>
+      <p:sp>
+        <p:nvSpPr>
+          <p:cNvPr id="4" name="Shape 1">
+            <a:extLst xmlns:a="http://schemas.openxmlformats.org/drawingml/2006/main">
+              <a:ext uri="{FF2B5EF4-FFF2-40B4-BE49-F238E27FC236}">
+                <a16:creationId xmlns:a16="http://schemas.microsoft.com/office/drawing/2014/main" id="{278EC71B-5FE1-4A7C-A640-5D651CF82027}"/>
+              </a:ext>
+            </a:extLst>
+          </p:cNvPr>
+          <p:cNvSpPr>
+            <a:spLocks xmlns:a="http://schemas.openxmlformats.org/drawingml/2006/main" noGrp="1"/>
+          </p:cNvSpPr>
+          <p:nvPr/>
+        </p:nvSpPr>
+        <p:spPr>
+          <a:xfrm xmlns:a="http://schemas.openxmlformats.org/drawingml/2006/main">
+            <a:off x="571500" y="286207"/>
+            <a:ext cx="11048695" cy="666598"/>
+          </a:xfrm>
+          <a:prstGeom xmlns:a="http://schemas.openxmlformats.org/drawingml/2006/main" prst="roundRect">
+            <a:avLst>
+              <a:gd name="adj" fmla="val 15677"/>
+            </a:avLst>
+          </a:prstGeom>
+          <a:solidFill xmlns:a="http://schemas.openxmlformats.org/drawingml/2006/main">
+            <a:srgbClr val="FFFFFF">
+              <a:alpha val="95000"/>
+            </a:srgbClr>
+          </a:solidFill>
+          <a:effectLst xmlns:a="http://schemas.openxmlformats.org/drawingml/2006/main">
+            <a:outerShdw blurRad="63500" dist="38100" dir="5400000" algn="bl" rotWithShape="0">
+              <a:srgbClr val="000000">
+                <a:alpha val="10000"/>
+              </a:srgbClr>
+            </a:outerShdw>
+          </a:effectLst>
+        </p:spPr>
+        <p:txBody>
+          <a:bodyPr xmlns:a="http://schemas.openxmlformats.org/drawingml/2006/main"/>
+          <a:lstStyle xmlns:a="http://schemas.openxmlformats.org/drawingml/2006/main"/>
+          <a:p xmlns:a="http://schemas.openxmlformats.org/drawingml/2006/main">
+            <a:endParaRPr/>
+          </a:p>
+        </p:txBody>
+      </p:sp>
+      <p:pic>
+        <p:nvPicPr>
+          <p:cNvPr id="43" name="Image 1"/>
+          <p:cNvPicPr>
+            <a:picLocks xmlns:a="http://schemas.openxmlformats.org/drawingml/2006/main" noChangeAspect="1"/>
+          </p:cNvPicPr>
+          <p:nvPr/>
+        </p:nvPicPr>
+        <p:blipFill>
+          <a:blip xmlns:r="http://schemas.openxmlformats.org/officeDocument/2006/relationships" xmlns:a="http://schemas.openxmlformats.org/drawingml/2006/main" r:embed="R43f2fcf545a74ddd"/>
+          <a:srcRect xmlns:a="http://schemas.openxmlformats.org/drawingml/2006/main" l="0" t="10" r="0" b="10"/>
+          <a:stretch xmlns:a="http://schemas.openxmlformats.org/drawingml/2006/main"/>
+        </p:blipFill>
+        <p:spPr>
+          <a:xfrm xmlns:a="http://schemas.openxmlformats.org/drawingml/2006/main">
+            <a:off x="857707" y="381305"/>
+            <a:ext cx="1266444" cy="476402"/>
+          </a:xfrm>
+          <a:prstGeom xmlns:a="http://schemas.openxmlformats.org/drawingml/2006/main" prst="rect">
+            <a:avLst/>
+          </a:prstGeom>
+        </p:spPr>
+      </p:pic>
+      <p:pic>
+        <p:nvPicPr>
+          <p:cNvPr id="44" name="Image 2"/>
+          <p:cNvPicPr>
+            <a:picLocks xmlns:a="http://schemas.openxmlformats.org/drawingml/2006/main" noChangeAspect="1"/>
+          </p:cNvPicPr>
+          <p:nvPr/>
+        </p:nvPicPr>
+        <p:blipFill>
+          <a:blip xmlns:r="http://schemas.openxmlformats.org/officeDocument/2006/relationships" xmlns:a="http://schemas.openxmlformats.org/drawingml/2006/main" r:embed="R41def692a7c347ee"/>
+          <a:srcRect xmlns:a="http://schemas.openxmlformats.org/drawingml/2006/main" l="0" t="0" r="0" b="0"/>
+          <a:stretch xmlns:a="http://schemas.openxmlformats.org/drawingml/2006/main"/>
+        </p:blipFill>
+        <p:spPr>
+          <a:xfrm xmlns:a="http://schemas.openxmlformats.org/drawingml/2006/main">
+            <a:off x="10858500" y="381305"/>
+            <a:ext cx="476402" cy="476402"/>
+          </a:xfrm>
+          <a:prstGeom xmlns:a="http://schemas.openxmlformats.org/drawingml/2006/main" prst="rect">
+            <a:avLst/>
+          </a:prstGeom>
+        </p:spPr>
+      </p:pic>
+      <p:sp>
+        <p:nvSpPr>
+          <p:cNvPr id="7" name="Shape 2">
+            <a:extLst xmlns:a="http://schemas.openxmlformats.org/drawingml/2006/main">
+              <a:ext uri="{FF2B5EF4-FFF2-40B4-BE49-F238E27FC236}">
+                <a16:creationId xmlns:a16="http://schemas.microsoft.com/office/drawing/2014/main" id="{7EBA136F-A561-41DF-85B8-BFDE7D906FB8}"/>
+              </a:ext>
+            </a:extLst>
+          </p:cNvPr>
+          <p:cNvSpPr>
+            <a:spLocks xmlns:a="http://schemas.openxmlformats.org/drawingml/2006/main" noGrp="1"/>
+          </p:cNvSpPr>
+          <p:nvPr/>
+        </p:nvSpPr>
+        <p:spPr>
+          <a:xfrm xmlns:a="http://schemas.openxmlformats.org/drawingml/2006/main">
+            <a:off x="571500" y="1190549"/>
+            <a:ext cx="75895" cy="409651"/>
+          </a:xfrm>
+          <a:prstGeom xmlns:a="http://schemas.openxmlformats.org/drawingml/2006/main" prst="rect">
+            <a:avLst/>
+          </a:prstGeom>
+          <a:solidFill xmlns:a="http://schemas.openxmlformats.org/drawingml/2006/main">
+            <a:srgbClr val="88E555"/>
+          </a:solidFill>
+        </p:spPr>
+        <p:txBody>
+          <a:bodyPr xmlns:a="http://schemas.openxmlformats.org/drawingml/2006/main"/>
+          <a:lstStyle xmlns:a="http://schemas.openxmlformats.org/drawingml/2006/main"/>
+          <a:p xmlns:a="http://schemas.openxmlformats.org/drawingml/2006/main">
+            <a:endParaRPr/>
+          </a:p>
+        </p:txBody>
+      </p:sp>
+      <p:sp>
+        <p:nvSpPr>
+          <p:cNvPr id="8" name="Text 3">
+            <a:extLst xmlns:a="http://schemas.openxmlformats.org/drawingml/2006/main">
+              <a:ext uri="{FF2B5EF4-FFF2-40B4-BE49-F238E27FC236}">
+                <a16:creationId xmlns:a16="http://schemas.microsoft.com/office/drawing/2014/main" id="{C85F60AA-A842-4CFB-A946-6744286FBCFB}"/>
+              </a:ext>
+            </a:extLst>
+          </p:cNvPr>
+          <p:cNvSpPr>
+            <a:spLocks xmlns:a="http://schemas.openxmlformats.org/drawingml/2006/main" noGrp="1"/>
+          </p:cNvSpPr>
+          <p:nvPr/>
+        </p:nvSpPr>
+        <p:spPr>
+          <a:xfrm xmlns:a="http://schemas.openxmlformats.org/drawingml/2006/main">
+            <a:off x="838505" y="1152144"/>
+            <a:ext cx="4624121" cy="467258"/>
+          </a:xfrm>
+          <a:prstGeom xmlns:a="http://schemas.openxmlformats.org/drawingml/2006/main" prst="rect">
+            <a:avLst/>
+          </a:prstGeom>
+          <a:noFill xmlns:a="http://schemas.openxmlformats.org/drawingml/2006/main"/>
+        </p:spPr>
+        <p:txBody>
+          <a:bodyPr xmlns:a="http://schemas.openxmlformats.org/drawingml/2006/main" wrap="square" lIns="0" tIns="0" rIns="0" bIns="0" anchor="ctr"/>
+          <a:lstStyle xmlns:a="http://schemas.openxmlformats.org/drawingml/2006/main"/>
+          <a:p xmlns:a="http://schemas.openxmlformats.org/drawingml/2006/main">
+            <a:pPr marL="0" indent="0" algn="l">
+              <a:buNone/>
+            </a:pPr>
+            <a:r>
+              <a:rPr sz="2600" b="1">
+                <a:solidFill>
+                  <a:srgbClr val="FFFFFF"/>
+                </a:solidFill>
+                <a:latin typeface="Poppins"/>
+                <a:ea typeface="Poppins"/>
+                <a:cs typeface="Poppins"/>
+              </a:rPr>
+              <a:t>Research, Code and References</a:t>
+            </a:r>
+            <a:endParaRPr sz="2600"/>
+          </a:p>
+        </p:txBody>
+      </p:sp>
+      <p:sp>
+        <p:nvSpPr>
+          <p:cNvPr id="9" name="Shape 4">
+            <a:extLst xmlns:a="http://schemas.openxmlformats.org/drawingml/2006/main">
+              <a:ext uri="{FF2B5EF4-FFF2-40B4-BE49-F238E27FC236}">
+                <a16:creationId xmlns:a16="http://schemas.microsoft.com/office/drawing/2014/main" id="{82CCE1F5-2E64-4213-B2CE-19F7C5B80504}"/>
+              </a:ext>
+            </a:extLst>
+          </p:cNvPr>
+          <p:cNvSpPr>
+            <a:spLocks xmlns:a="http://schemas.openxmlformats.org/drawingml/2006/main" noGrp="1"/>
+          </p:cNvSpPr>
+          <p:nvPr/>
+        </p:nvSpPr>
+        <p:spPr>
+          <a:xfrm xmlns:a="http://schemas.openxmlformats.org/drawingml/2006/main">
+            <a:off x="571500" y="1830629"/>
+            <a:ext cx="11048695" cy="4743907"/>
+          </a:xfrm>
+          <a:prstGeom xmlns:a="http://schemas.openxmlformats.org/drawingml/2006/main" prst="roundRect">
+            <a:avLst>
+              <a:gd name="adj" fmla="val 619"/>
+            </a:avLst>
+          </a:prstGeom>
+          <a:solidFill xmlns:a="http://schemas.openxmlformats.org/drawingml/2006/main">
+            <a:srgbClr val="FFFFFF">
+              <a:alpha val="5000"/>
+            </a:srgbClr>
+          </a:solidFill>
+          <a:ln xmlns:a="http://schemas.openxmlformats.org/drawingml/2006/main" w="12700">
+            <a:solidFill>
+              <a:srgbClr val="88E555">
+                <a:alpha val="30000"/>
+              </a:srgbClr>
+            </a:solidFill>
+            <a:prstDash val="solid"/>
+          </a:ln>
+        </p:spPr>
+        <p:txBody>
+          <a:bodyPr xmlns:a="http://schemas.openxmlformats.org/drawingml/2006/main"/>
+          <a:lstStyle xmlns:a="http://schemas.openxmlformats.org/drawingml/2006/main"/>
+          <a:p xmlns:a="http://schemas.openxmlformats.org/drawingml/2006/main">
+            <a:endParaRPr/>
+          </a:p>
+        </p:txBody>
+      </p:sp>
+      <p:sp>
+        <p:nvSpPr>
+          <p:cNvPr id="10" name="Shape 5">
+            <a:extLst xmlns:a="http://schemas.openxmlformats.org/drawingml/2006/main">
+              <a:ext uri="{FF2B5EF4-FFF2-40B4-BE49-F238E27FC236}">
+                <a16:creationId xmlns:a16="http://schemas.microsoft.com/office/drawing/2014/main" id="{3825CC24-1991-4317-89CA-9C93F0CD54DA}"/>
+              </a:ext>
+            </a:extLst>
+          </p:cNvPr>
+          <p:cNvSpPr>
+            <a:spLocks xmlns:a="http://schemas.openxmlformats.org/drawingml/2006/main" noGrp="1"/>
+          </p:cNvSpPr>
+          <p:nvPr/>
+        </p:nvSpPr>
+        <p:spPr>
+          <a:xfrm xmlns:a="http://schemas.openxmlformats.org/drawingml/2006/main">
+            <a:off x="571500" y="1830629"/>
+            <a:ext cx="190195" cy="190195"/>
+          </a:xfrm>
+          <a:prstGeom xmlns:a="http://schemas.openxmlformats.org/drawingml/2006/main" prst="roundRect">
+            <a:avLst>
+              <a:gd name="adj" fmla="val 192308"/>
+            </a:avLst>
+          </a:prstGeom>
+          <a:noFill xmlns:a="http://schemas.openxmlformats.org/drawingml/2006/main"/>
+          <a:ln xmlns:a="http://schemas.openxmlformats.org/drawingml/2006/main" w="38100">
+            <a:solidFill>
+              <a:srgbClr val="88E555"/>
+            </a:solidFill>
+            <a:prstDash val="solid"/>
+          </a:ln>
+        </p:spPr>
+        <p:txBody>
+          <a:bodyPr xmlns:a="http://schemas.openxmlformats.org/drawingml/2006/main"/>
+          <a:lstStyle xmlns:a="http://schemas.openxmlformats.org/drawingml/2006/main"/>
+          <a:p xmlns:a="http://schemas.openxmlformats.org/drawingml/2006/main">
+            <a:endParaRPr/>
+          </a:p>
+        </p:txBody>
+      </p:sp>
+      <p:sp>
+        <p:nvSpPr>
+          <p:cNvPr id="11" name="Shape 6">
+            <a:extLst xmlns:a="http://schemas.openxmlformats.org/drawingml/2006/main">
+              <a:ext uri="{FF2B5EF4-FFF2-40B4-BE49-F238E27FC236}">
+                <a16:creationId xmlns:a16="http://schemas.microsoft.com/office/drawing/2014/main" id="{28BE731D-AC61-41AE-B8FB-85ED6386DB32}"/>
+              </a:ext>
+            </a:extLst>
+          </p:cNvPr>
+          <p:cNvSpPr>
+            <a:spLocks xmlns:a="http://schemas.openxmlformats.org/drawingml/2006/main" noGrp="1"/>
+          </p:cNvSpPr>
+          <p:nvPr/>
+        </p:nvSpPr>
+        <p:spPr>
+          <a:xfrm xmlns:a="http://schemas.openxmlformats.org/drawingml/2006/main">
+            <a:off x="11430000" y="1830629"/>
+            <a:ext cx="190195" cy="190195"/>
+          </a:xfrm>
+          <a:prstGeom xmlns:a="http://schemas.openxmlformats.org/drawingml/2006/main" prst="rect">
+            <a:avLst/>
+          </a:prstGeom>
+          <a:noFill xmlns:a="http://schemas.openxmlformats.org/drawingml/2006/main"/>
+          <a:ln xmlns:a="http://schemas.openxmlformats.org/drawingml/2006/main" w="38100">
+            <a:solidFill>
+              <a:srgbClr val="88E555"/>
+            </a:solidFill>
+            <a:prstDash val="solid"/>
+          </a:ln>
+        </p:spPr>
+        <p:txBody>
+          <a:bodyPr xmlns:a="http://schemas.openxmlformats.org/drawingml/2006/main"/>
+          <a:lstStyle xmlns:a="http://schemas.openxmlformats.org/drawingml/2006/main"/>
+          <a:p xmlns:a="http://schemas.openxmlformats.org/drawingml/2006/main">
+            <a:endParaRPr/>
+          </a:p>
+        </p:txBody>
+      </p:sp>
+      <p:sp>
+        <p:nvSpPr>
+          <p:cNvPr id="12" name="Shape 7">
+            <a:extLst xmlns:a="http://schemas.openxmlformats.org/drawingml/2006/main">
+              <a:ext uri="{FF2B5EF4-FFF2-40B4-BE49-F238E27FC236}">
+                <a16:creationId xmlns:a16="http://schemas.microsoft.com/office/drawing/2014/main" id="{44E0D3B1-CF7A-4253-8535-98420E9B0299}"/>
+              </a:ext>
+            </a:extLst>
+          </p:cNvPr>
+          <p:cNvSpPr>
+            <a:spLocks xmlns:a="http://schemas.openxmlformats.org/drawingml/2006/main" noGrp="1"/>
+          </p:cNvSpPr>
+          <p:nvPr/>
+        </p:nvSpPr>
+        <p:spPr>
+          <a:xfrm xmlns:a="http://schemas.openxmlformats.org/drawingml/2006/main">
+            <a:off x="571500" y="6381598"/>
+            <a:ext cx="190195" cy="190195"/>
+          </a:xfrm>
+          <a:prstGeom xmlns:a="http://schemas.openxmlformats.org/drawingml/2006/main" prst="rect">
+            <a:avLst/>
+          </a:prstGeom>
+          <a:noFill xmlns:a="http://schemas.openxmlformats.org/drawingml/2006/main"/>
+          <a:ln xmlns:a="http://schemas.openxmlformats.org/drawingml/2006/main" w="38100">
+            <a:solidFill>
+              <a:srgbClr val="88E555"/>
+            </a:solidFill>
+            <a:prstDash val="solid"/>
+          </a:ln>
+        </p:spPr>
+        <p:txBody>
+          <a:bodyPr xmlns:a="http://schemas.openxmlformats.org/drawingml/2006/main"/>
+          <a:lstStyle xmlns:a="http://schemas.openxmlformats.org/drawingml/2006/main"/>
+          <a:p xmlns:a="http://schemas.openxmlformats.org/drawingml/2006/main">
+            <a:endParaRPr/>
+          </a:p>
+        </p:txBody>
+      </p:sp>
+      <p:sp>
+        <p:nvSpPr>
+          <p:cNvPr id="13" name="Shape 8">
+            <a:extLst xmlns:a="http://schemas.openxmlformats.org/drawingml/2006/main">
+              <a:ext uri="{FF2B5EF4-FFF2-40B4-BE49-F238E27FC236}">
+                <a16:creationId xmlns:a16="http://schemas.microsoft.com/office/drawing/2014/main" id="{D69008A7-0E40-45A2-9E4B-7333E4370058}"/>
+              </a:ext>
+            </a:extLst>
+          </p:cNvPr>
+          <p:cNvSpPr>
+            <a:spLocks xmlns:a="http://schemas.openxmlformats.org/drawingml/2006/main" noGrp="1"/>
+          </p:cNvSpPr>
+          <p:nvPr/>
+        </p:nvSpPr>
+        <p:spPr>
+          <a:xfrm xmlns:a="http://schemas.openxmlformats.org/drawingml/2006/main">
+            <a:off x="11430000" y="6381598"/>
+            <a:ext cx="190195" cy="190195"/>
+          </a:xfrm>
+          <a:prstGeom xmlns:a="http://schemas.openxmlformats.org/drawingml/2006/main" prst="rect">
+            <a:avLst/>
+          </a:prstGeom>
+          <a:noFill xmlns:a="http://schemas.openxmlformats.org/drawingml/2006/main"/>
+          <a:ln xmlns:a="http://schemas.openxmlformats.org/drawingml/2006/main" w="38100">
+            <a:solidFill>
+              <a:srgbClr val="88E555"/>
+            </a:solidFill>
+            <a:prstDash val="solid"/>
+          </a:ln>
+        </p:spPr>
+        <p:txBody>
+          <a:bodyPr xmlns:a="http://schemas.openxmlformats.org/drawingml/2006/main"/>
+          <a:lstStyle xmlns:a="http://schemas.openxmlformats.org/drawingml/2006/main"/>
+          <a:p xmlns:a="http://schemas.openxmlformats.org/drawingml/2006/main">
+            <a:endParaRPr/>
+          </a:p>
+        </p:txBody>
+      </p:sp>
+      <p:sp>
+        <p:nvSpPr>
+          <p:cNvPr id="14" name="Shape 9">
+            <a:extLst xmlns:a="http://schemas.openxmlformats.org/drawingml/2006/main">
+              <a:ext uri="{FF2B5EF4-FFF2-40B4-BE49-F238E27FC236}">
+                <a16:creationId xmlns:a16="http://schemas.microsoft.com/office/drawing/2014/main" id="{95375588-F903-4DB8-B067-2FA74878F769}"/>
+              </a:ext>
+            </a:extLst>
+          </p:cNvPr>
+          <p:cNvSpPr>
+            <a:spLocks xmlns:a="http://schemas.openxmlformats.org/drawingml/2006/main" noGrp="1"/>
+          </p:cNvSpPr>
+          <p:nvPr/>
+        </p:nvSpPr>
+        <p:spPr>
+          <a:xfrm xmlns:a="http://schemas.openxmlformats.org/drawingml/2006/main">
+            <a:off x="961949" y="2173529"/>
+            <a:ext cx="476402" cy="476402"/>
+          </a:xfrm>
+          <a:prstGeom xmlns:a="http://schemas.openxmlformats.org/drawingml/2006/main" prst="ellipse">
+            <a:avLst/>
+          </a:prstGeom>
+          <a:solidFill xmlns:a="http://schemas.openxmlformats.org/drawingml/2006/main">
+            <a:srgbClr val="273383">
+              <a:alpha val="50000"/>
+            </a:srgbClr>
+          </a:solidFill>
+          <a:ln xmlns:a="http://schemas.openxmlformats.org/drawingml/2006/main" w="25400">
+            <a:solidFill>
+              <a:srgbClr val="AEFF82"/>
+            </a:solidFill>
+            <a:prstDash val="solid"/>
+          </a:ln>
+        </p:spPr>
+        <p:txBody>
+          <a:bodyPr xmlns:a="http://schemas.openxmlformats.org/drawingml/2006/main"/>
+          <a:lstStyle xmlns:a="http://schemas.openxmlformats.org/drawingml/2006/main"/>
+          <a:p xmlns:a="http://schemas.openxmlformats.org/drawingml/2006/main">
+            <a:endParaRPr/>
+          </a:p>
+        </p:txBody>
+      </p:sp>
+      <p:pic>
+        <p:nvPicPr>
+          <p:cNvPr id="53" name="Image 3"/>
+          <p:cNvPicPr>
+            <a:picLocks xmlns:a="http://schemas.openxmlformats.org/drawingml/2006/main" noChangeAspect="1"/>
+          </p:cNvPicPr>
+          <p:nvPr/>
+        </p:nvPicPr>
+        <p:blipFill>
+          <a:blip xmlns:r="http://schemas.openxmlformats.org/officeDocument/2006/relationships" xmlns:a="http://schemas.openxmlformats.org/drawingml/2006/main" r:embed="R808b02de48434bc3"/>
+          <a:srcRect xmlns:a="http://schemas.openxmlformats.org/drawingml/2006/main" l="0" t="0" r="0" b="0"/>
+          <a:stretch xmlns:a="http://schemas.openxmlformats.org/drawingml/2006/main"/>
+        </p:blipFill>
+        <p:spPr>
+          <a:xfrm xmlns:a="http://schemas.openxmlformats.org/drawingml/2006/main">
+            <a:off x="1086307" y="2297887"/>
+            <a:ext cx="228600" cy="228600"/>
+          </a:xfrm>
+          <a:prstGeom xmlns:a="http://schemas.openxmlformats.org/drawingml/2006/main" prst="rect">
+            <a:avLst/>
+          </a:prstGeom>
+        </p:spPr>
+      </p:pic>
+      <p:sp>
+        <p:nvSpPr>
+          <p:cNvPr id="16" name="Text 10">
+            <a:extLst xmlns:a="http://schemas.openxmlformats.org/drawingml/2006/main">
+              <a:ext uri="{FF2B5EF4-FFF2-40B4-BE49-F238E27FC236}">
+                <a16:creationId xmlns:a16="http://schemas.microsoft.com/office/drawing/2014/main" id="{AE7389F1-75D7-49FE-BC3F-1962A1D15DE1}"/>
+              </a:ext>
+            </a:extLst>
+          </p:cNvPr>
+          <p:cNvSpPr>
+            <a:spLocks xmlns:a="http://schemas.openxmlformats.org/drawingml/2006/main" noGrp="1"/>
+          </p:cNvSpPr>
+          <p:nvPr/>
+        </p:nvSpPr>
+        <p:spPr>
+          <a:xfrm xmlns:a="http://schemas.openxmlformats.org/drawingml/2006/main">
+            <a:off x="1628546" y="2173529"/>
+            <a:ext cx="3810305" cy="267005"/>
+          </a:xfrm>
+          <a:prstGeom xmlns:a="http://schemas.openxmlformats.org/drawingml/2006/main" prst="rect">
+            <a:avLst/>
+          </a:prstGeom>
+          <a:noFill xmlns:a="http://schemas.openxmlformats.org/drawingml/2006/main"/>
+        </p:spPr>
+        <p:txBody>
+          <a:bodyPr xmlns:a="http://schemas.openxmlformats.org/drawingml/2006/main" wrap="square" lIns="0" tIns="0" rIns="0" bIns="0" anchor="ctr"/>
+          <a:lstStyle xmlns:a="http://schemas.openxmlformats.org/drawingml/2006/main"/>
+          <a:p xmlns:a="http://schemas.openxmlformats.org/drawingml/2006/main">
+            <a:pPr marL="0" indent="0" algn="l">
+              <a:buNone/>
+            </a:pPr>
+            <a:r>
+              <a:rPr sz="1500" b="1">
+                <a:solidFill>
+                  <a:srgbClr val="88E555"/>
+                </a:solidFill>
+                <a:latin typeface="Poppins"/>
+                <a:ea typeface="Poppins"/>
+                <a:cs typeface="Poppins"/>
+              </a:rPr>
+              <a:t>Research Basis + Reproducibility</a:t>
+            </a:r>
+            <a:endParaRPr sz="1500"/>
+          </a:p>
+        </p:txBody>
+      </p:sp>
+      <p:sp>
+        <p:nvSpPr>
+          <p:cNvPr id="17" name="Text 11">
+            <a:extLst xmlns:a="http://schemas.openxmlformats.org/drawingml/2006/main">
+              <a:ext uri="{FF2B5EF4-FFF2-40B4-BE49-F238E27FC236}">
+                <a16:creationId xmlns:a16="http://schemas.microsoft.com/office/drawing/2014/main" id="{FEF4022D-E493-4C00-8470-A4FCC3516AE1}"/>
+              </a:ext>
+            </a:extLst>
+          </p:cNvPr>
+          <p:cNvSpPr>
+            <a:spLocks xmlns:a="http://schemas.openxmlformats.org/drawingml/2006/main" noGrp="1"/>
+          </p:cNvSpPr>
+          <p:nvPr/>
+        </p:nvSpPr>
+        <p:spPr>
+          <a:xfrm xmlns:a="http://schemas.openxmlformats.org/drawingml/2006/main">
+            <a:off x="1628546" y="2516429"/>
+            <a:ext cx="5701284" cy="191110"/>
+          </a:xfrm>
+          <a:prstGeom xmlns:a="http://schemas.openxmlformats.org/drawingml/2006/main" prst="rect">
+            <a:avLst/>
+          </a:prstGeom>
+          <a:noFill xmlns:a="http://schemas.openxmlformats.org/drawingml/2006/main"/>
+        </p:spPr>
+        <p:txBody>
+          <a:bodyPr xmlns:a="http://schemas.openxmlformats.org/drawingml/2006/main" wrap="square" lIns="0" tIns="0" rIns="0" bIns="0" anchor="ctr"/>
+          <a:lstStyle xmlns:a="http://schemas.openxmlformats.org/drawingml/2006/main"/>
+          <a:p xmlns:a="http://schemas.openxmlformats.org/drawingml/2006/main">
+            <a:pPr marL="0" indent="0" algn="l">
+              <a:buNone/>
+            </a:pPr>
+            <a:r>
+              <a:rPr sz="1000">
+                <a:solidFill>
+                  <a:srgbClr val="D1D5DB"/>
+                </a:solidFill>
+                <a:latin typeface="Poppins"/>
+                <a:ea typeface="Poppins"/>
+                <a:cs typeface="Poppins"/>
+              </a:rPr>
+              <a:t>Implemented evidence and submission links</a:t>
+            </a:r>
+            <a:endParaRPr sz="1000"/>
+          </a:p>
+        </p:txBody>
+      </p:sp>
+      <p:sp>
+        <p:nvSpPr>
+          <p:cNvPr id="18" name="Shape 12">
+            <a:extLst xmlns:a="http://schemas.openxmlformats.org/drawingml/2006/main">
+              <a:ext uri="{FF2B5EF4-FFF2-40B4-BE49-F238E27FC236}">
+                <a16:creationId xmlns:a16="http://schemas.microsoft.com/office/drawing/2014/main" id="{7379F5BC-BB2E-49A8-8A77-C43AD7E0D550}"/>
+              </a:ext>
+            </a:extLst>
+          </p:cNvPr>
+          <p:cNvSpPr>
+            <a:spLocks xmlns:a="http://schemas.openxmlformats.org/drawingml/2006/main" noGrp="1"/>
+          </p:cNvSpPr>
+          <p:nvPr/>
+        </p:nvSpPr>
+        <p:spPr>
+          <a:xfrm xmlns:a="http://schemas.openxmlformats.org/drawingml/2006/main">
+            <a:off x="1628546" y="2783434"/>
+            <a:ext cx="9601200" cy="1067105"/>
+          </a:xfrm>
+          <a:prstGeom xmlns:a="http://schemas.openxmlformats.org/drawingml/2006/main" prst="roundRect">
+            <a:avLst>
+              <a:gd name="adj" fmla="val 6121"/>
+            </a:avLst>
+          </a:prstGeom>
+          <a:solidFill xmlns:a="http://schemas.openxmlformats.org/drawingml/2006/main">
+            <a:srgbClr val="1E3A8A">
+              <a:alpha val="40000"/>
+            </a:srgbClr>
+          </a:solidFill>
+          <a:ln xmlns:a="http://schemas.openxmlformats.org/drawingml/2006/main" w="12700">
+            <a:solidFill>
+              <a:srgbClr val="1D4ED8"/>
+            </a:solidFill>
+            <a:prstDash val="solid"/>
+          </a:ln>
+        </p:spPr>
+        <p:txBody>
+          <a:bodyPr xmlns:a="http://schemas.openxmlformats.org/drawingml/2006/main"/>
+          <a:lstStyle xmlns:a="http://schemas.openxmlformats.org/drawingml/2006/main"/>
+          <a:p xmlns:a="http://schemas.openxmlformats.org/drawingml/2006/main">
+            <a:endParaRPr/>
+          </a:p>
+        </p:txBody>
+      </p:sp>
+      <p:sp>
+        <p:nvSpPr>
+          <p:cNvPr id="19" name="Text 13">
+            <a:extLst xmlns:a="http://schemas.openxmlformats.org/drawingml/2006/main">
+              <a:ext uri="{FF2B5EF4-FFF2-40B4-BE49-F238E27FC236}">
+                <a16:creationId xmlns:a16="http://schemas.microsoft.com/office/drawing/2014/main" id="{3B5C7BFA-93F7-4CBE-B016-734BAF9860A5}"/>
+              </a:ext>
+            </a:extLst>
+          </p:cNvPr>
+          <p:cNvSpPr>
+            <a:spLocks xmlns:a="http://schemas.openxmlformats.org/drawingml/2006/main" noGrp="1"/>
+          </p:cNvSpPr>
+          <p:nvPr/>
+        </p:nvSpPr>
+        <p:spPr>
+          <a:xfrm xmlns:a="http://schemas.openxmlformats.org/drawingml/2006/main">
+            <a:off x="1790395" y="2945282"/>
+            <a:ext cx="5544007" cy="219456"/>
+          </a:xfrm>
+          <a:prstGeom xmlns:a="http://schemas.openxmlformats.org/drawingml/2006/main" prst="rect">
+            <a:avLst/>
+          </a:prstGeom>
+          <a:noFill xmlns:a="http://schemas.openxmlformats.org/drawingml/2006/main"/>
+        </p:spPr>
+        <p:txBody>
+          <a:bodyPr xmlns:a="http://schemas.openxmlformats.org/drawingml/2006/main" wrap="square" lIns="0" tIns="0" rIns="0" bIns="0" anchor="ctr"/>
+          <a:lstStyle xmlns:a="http://schemas.openxmlformats.org/drawingml/2006/main"/>
+          <a:p xmlns:a="http://schemas.openxmlformats.org/drawingml/2006/main">
+            <a:pPr marL="0" indent="0" algn="l">
+              <a:buNone/>
+            </a:pPr>
+            <a:r>
+              <a:rPr sz="1200" i="1">
+                <a:solidFill>
+                  <a:srgbClr val="FFFFFF">
+                    <a:alpha val="70000"/>
+                  </a:srgbClr>
+                </a:solidFill>
+                <a:latin typeface="Poppins"/>
+                <a:ea typeface="Poppins"/>
+                <a:cs typeface="Poppins"/>
+              </a:rPr>
+              <a:t>2026 UCAN and ShiftLUT motivate wider spatial context; our 5x5 depthwise ablation is the measured adaptation.
+GitHub: github.com/Vikaash301/kla-semicon   Video: [ADD OPTIONAL DEMO URL]</a:t>
+            </a:r>
+            <a:endParaRPr sz="1200"/>
+          </a:p>
+        </p:txBody>
+      </p:sp>
+      <p:sp>
+        <p:nvSpPr>
+          <p:cNvPr id="20" name="Shape 14">
+            <a:extLst xmlns:a="http://schemas.openxmlformats.org/drawingml/2006/main">
+              <a:ext uri="{FF2B5EF4-FFF2-40B4-BE49-F238E27FC236}">
+                <a16:creationId xmlns:a16="http://schemas.microsoft.com/office/drawing/2014/main" id="{B1DCBEC9-7DB7-4767-A007-6A2DA0389783}"/>
+              </a:ext>
+            </a:extLst>
+          </p:cNvPr>
+          <p:cNvSpPr>
+            <a:spLocks xmlns:a="http://schemas.openxmlformats.org/drawingml/2006/main" noGrp="1"/>
+          </p:cNvSpPr>
+          <p:nvPr/>
+        </p:nvSpPr>
+        <p:spPr>
+          <a:xfrm xmlns:a="http://schemas.openxmlformats.org/drawingml/2006/main">
+            <a:off x="961949" y="4155034"/>
+            <a:ext cx="476402" cy="476402"/>
+          </a:xfrm>
+          <a:prstGeom xmlns:a="http://schemas.openxmlformats.org/drawingml/2006/main" prst="ellipse">
+            <a:avLst/>
+          </a:prstGeom>
+          <a:solidFill xmlns:a="http://schemas.openxmlformats.org/drawingml/2006/main">
+            <a:srgbClr val="273383">
+              <a:alpha val="50000"/>
+            </a:srgbClr>
+          </a:solidFill>
+          <a:ln xmlns:a="http://schemas.openxmlformats.org/drawingml/2006/main" w="25400">
+            <a:solidFill>
+              <a:srgbClr val="AEFF82"/>
+            </a:solidFill>
+            <a:prstDash val="solid"/>
+          </a:ln>
+        </p:spPr>
+        <p:txBody>
+          <a:bodyPr xmlns:a="http://schemas.openxmlformats.org/drawingml/2006/main"/>
+          <a:lstStyle xmlns:a="http://schemas.openxmlformats.org/drawingml/2006/main"/>
+          <a:p xmlns:a="http://schemas.openxmlformats.org/drawingml/2006/main">
+            <a:endParaRPr/>
+          </a:p>
+        </p:txBody>
+      </p:sp>
+      <p:pic>
+        <p:nvPicPr>
+          <p:cNvPr id="59" name="Image 4"/>
+          <p:cNvPicPr>
+            <a:picLocks xmlns:a="http://schemas.openxmlformats.org/drawingml/2006/main" noChangeAspect="1"/>
+          </p:cNvPicPr>
+          <p:nvPr/>
+        </p:nvPicPr>
+        <p:blipFill>
+          <a:blip xmlns:r="http://schemas.openxmlformats.org/officeDocument/2006/relationships" xmlns:a="http://schemas.openxmlformats.org/drawingml/2006/main" r:embed="Reed5ab06475047d1"/>
+          <a:srcRect xmlns:a="http://schemas.openxmlformats.org/drawingml/2006/main" l="-80" t="0" r="-80" b="0"/>
+          <a:stretch xmlns:a="http://schemas.openxmlformats.org/drawingml/2006/main"/>
+        </p:blipFill>
+        <p:spPr>
+          <a:xfrm xmlns:a="http://schemas.openxmlformats.org/drawingml/2006/main">
+            <a:off x="1057046" y="4279392"/>
+            <a:ext cx="286207" cy="228600"/>
+          </a:xfrm>
+          <a:prstGeom xmlns:a="http://schemas.openxmlformats.org/drawingml/2006/main" prst="rect">
+            <a:avLst/>
+          </a:prstGeom>
+        </p:spPr>
+      </p:pic>
+      <p:sp>
+        <p:nvSpPr>
+          <p:cNvPr id="22" name="Text 15">
+            <a:extLst xmlns:a="http://schemas.openxmlformats.org/drawingml/2006/main">
+              <a:ext uri="{FF2B5EF4-FFF2-40B4-BE49-F238E27FC236}">
+                <a16:creationId xmlns:a16="http://schemas.microsoft.com/office/drawing/2014/main" id="{6BFB0B10-EC6D-4447-8EEE-561D39E0F166}"/>
+              </a:ext>
+            </a:extLst>
+          </p:cNvPr>
+          <p:cNvSpPr>
+            <a:spLocks xmlns:a="http://schemas.openxmlformats.org/drawingml/2006/main" noGrp="1"/>
+          </p:cNvSpPr>
+          <p:nvPr/>
+        </p:nvSpPr>
+        <p:spPr>
+          <a:xfrm xmlns:a="http://schemas.openxmlformats.org/drawingml/2006/main">
+            <a:off x="1628546" y="4155034"/>
+            <a:ext cx="2343607" cy="267005"/>
+          </a:xfrm>
+          <a:prstGeom xmlns:a="http://schemas.openxmlformats.org/drawingml/2006/main" prst="rect">
+            <a:avLst/>
+          </a:prstGeom>
+          <a:noFill xmlns:a="http://schemas.openxmlformats.org/drawingml/2006/main"/>
+        </p:spPr>
+        <p:txBody>
+          <a:bodyPr xmlns:a="http://schemas.openxmlformats.org/drawingml/2006/main" wrap="square" lIns="0" tIns="0" rIns="0" bIns="0" anchor="ctr"/>
+          <a:lstStyle xmlns:a="http://schemas.openxmlformats.org/drawingml/2006/main"/>
+          <a:p xmlns:a="http://schemas.openxmlformats.org/drawingml/2006/main">
+            <a:pPr marL="0" indent="0" algn="l">
+              <a:buNone/>
+            </a:pPr>
+            <a:r>
+              <a:rPr sz="1500" b="1">
+                <a:solidFill>
+                  <a:srgbClr val="88E555"/>
+                </a:solidFill>
+                <a:latin typeface="Poppins"/>
+                <a:ea typeface="Poppins"/>
+                <a:cs typeface="Poppins"/>
+              </a:rPr>
+              <a:t>References &amp; Citations</a:t>
+            </a:r>
+            <a:endParaRPr sz="1500"/>
+          </a:p>
+        </p:txBody>
+      </p:sp>
+      <p:sp>
+        <p:nvSpPr>
+          <p:cNvPr id="23" name="Text 16">
+            <a:extLst xmlns:a="http://schemas.openxmlformats.org/drawingml/2006/main">
+              <a:ext uri="{FF2B5EF4-FFF2-40B4-BE49-F238E27FC236}">
+                <a16:creationId xmlns:a16="http://schemas.microsoft.com/office/drawing/2014/main" id="{86363100-0497-428A-81EA-F4FF828D7BA9}"/>
+              </a:ext>
+            </a:extLst>
+          </p:cNvPr>
+          <p:cNvSpPr>
+            <a:spLocks xmlns:a="http://schemas.openxmlformats.org/drawingml/2006/main" noGrp="1"/>
+          </p:cNvSpPr>
+          <p:nvPr/>
+        </p:nvSpPr>
+        <p:spPr>
+          <a:xfrm xmlns:a="http://schemas.openxmlformats.org/drawingml/2006/main">
+            <a:off x="1628546" y="4497934"/>
+            <a:ext cx="2767889" cy="191110"/>
+          </a:xfrm>
+          <a:prstGeom xmlns:a="http://schemas.openxmlformats.org/drawingml/2006/main" prst="rect">
+            <a:avLst/>
+          </a:prstGeom>
+          <a:noFill xmlns:a="http://schemas.openxmlformats.org/drawingml/2006/main"/>
+        </p:spPr>
+        <p:txBody>
+          <a:bodyPr xmlns:a="http://schemas.openxmlformats.org/drawingml/2006/main" wrap="square" lIns="0" tIns="0" rIns="0" bIns="0" anchor="ctr"/>
+          <a:lstStyle xmlns:a="http://schemas.openxmlformats.org/drawingml/2006/main"/>
+          <a:p xmlns:a="http://schemas.openxmlformats.org/drawingml/2006/main">
+            <a:pPr marL="0" indent="0" algn="l">
+              <a:buNone/>
+            </a:pPr>
+            <a:r>
+              <a:rPr sz="1000">
+                <a:solidFill>
+                  <a:srgbClr val="D1D5DB"/>
+                </a:solidFill>
+                <a:latin typeface="Poppins"/>
+                <a:ea typeface="Poppins"/>
+                <a:cs typeface="Poppins"/>
+              </a:rPr>
+              <a:t>Primary sources; full verified list in REFERENCES.md</a:t>
+            </a:r>
+            <a:endParaRPr sz="1000"/>
+          </a:p>
+        </p:txBody>
+      </p:sp>
+      <p:sp>
+        <p:nvSpPr>
+          <p:cNvPr id="24" name="Shape 17">
+            <a:extLst xmlns:a="http://schemas.openxmlformats.org/drawingml/2006/main">
+              <a:ext uri="{FF2B5EF4-FFF2-40B4-BE49-F238E27FC236}">
+                <a16:creationId xmlns:a16="http://schemas.microsoft.com/office/drawing/2014/main" id="{73305CAA-8728-4677-8131-61C32640DAD2}"/>
+              </a:ext>
+            </a:extLst>
+          </p:cNvPr>
+          <p:cNvSpPr>
+            <a:spLocks xmlns:a="http://schemas.openxmlformats.org/drawingml/2006/main" noGrp="1"/>
+          </p:cNvSpPr>
+          <p:nvPr/>
+        </p:nvSpPr>
+        <p:spPr>
+          <a:xfrm xmlns:a="http://schemas.openxmlformats.org/drawingml/2006/main">
+            <a:off x="1628546" y="4764938"/>
+            <a:ext cx="9601200" cy="1410005"/>
+          </a:xfrm>
+          <a:prstGeom xmlns:a="http://schemas.openxmlformats.org/drawingml/2006/main" prst="roundRect">
+            <a:avLst>
+              <a:gd name="adj" fmla="val 3505"/>
+            </a:avLst>
+          </a:prstGeom>
+          <a:solidFill xmlns:a="http://schemas.openxmlformats.org/drawingml/2006/main">
+            <a:srgbClr val="1E3A8A">
+              <a:alpha val="40000"/>
+            </a:srgbClr>
+          </a:solidFill>
+          <a:ln xmlns:a="http://schemas.openxmlformats.org/drawingml/2006/main" w="12700">
+            <a:solidFill>
+              <a:srgbClr val="1D4ED8"/>
+            </a:solidFill>
+            <a:prstDash val="solid"/>
+          </a:ln>
+        </p:spPr>
+        <p:txBody>
+          <a:bodyPr xmlns:a="http://schemas.openxmlformats.org/drawingml/2006/main"/>
+          <a:lstStyle xmlns:a="http://schemas.openxmlformats.org/drawingml/2006/main"/>
+          <a:p xmlns:a="http://schemas.openxmlformats.org/drawingml/2006/main">
+            <a:endParaRPr/>
+          </a:p>
+        </p:txBody>
+      </p:sp>
+      <p:sp>
+        <p:nvSpPr>
+          <p:cNvPr id="25" name="Shape 18">
+            <a:extLst xmlns:a="http://schemas.openxmlformats.org/drawingml/2006/main">
+              <a:ext uri="{FF2B5EF4-FFF2-40B4-BE49-F238E27FC236}">
+                <a16:creationId xmlns:a16="http://schemas.microsoft.com/office/drawing/2014/main" id="{3DB6E72D-8F93-4D68-BCAE-C9578A37177F}"/>
+              </a:ext>
+            </a:extLst>
+          </p:cNvPr>
+          <p:cNvSpPr>
+            <a:spLocks xmlns:a="http://schemas.openxmlformats.org/drawingml/2006/main" noGrp="1"/>
+          </p:cNvSpPr>
+          <p:nvPr/>
+        </p:nvSpPr>
+        <p:spPr>
+          <a:xfrm xmlns:a="http://schemas.openxmlformats.org/drawingml/2006/main">
+            <a:off x="1790395" y="5232197"/>
+            <a:ext cx="9277502" cy="9144"/>
+          </a:xfrm>
+          <a:prstGeom xmlns:a="http://schemas.openxmlformats.org/drawingml/2006/main" prst="rect">
+            <a:avLst/>
+          </a:prstGeom>
+          <a:solidFill xmlns:a="http://schemas.openxmlformats.org/drawingml/2006/main">
+            <a:srgbClr val="1E40AF">
+              <a:alpha val="30000"/>
+            </a:srgbClr>
+          </a:solidFill>
+        </p:spPr>
+        <p:txBody>
+          <a:bodyPr xmlns:a="http://schemas.openxmlformats.org/drawingml/2006/main"/>
+          <a:lstStyle xmlns:a="http://schemas.openxmlformats.org/drawingml/2006/main"/>
+          <a:p xmlns:a="http://schemas.openxmlformats.org/drawingml/2006/main">
+            <a:endParaRPr/>
+          </a:p>
+        </p:txBody>
+      </p:sp>
+      <p:sp>
+        <p:nvSpPr>
+          <p:cNvPr id="26" name="Text 19">
+            <a:extLst xmlns:a="http://schemas.openxmlformats.org/drawingml/2006/main">
+              <a:ext uri="{FF2B5EF4-FFF2-40B4-BE49-F238E27FC236}">
+                <a16:creationId xmlns:a16="http://schemas.microsoft.com/office/drawing/2014/main" id="{DDD962C3-A587-4204-AF8E-66B06E9C3BCD}"/>
+              </a:ext>
+            </a:extLst>
+          </p:cNvPr>
+          <p:cNvSpPr>
+            <a:spLocks xmlns:a="http://schemas.openxmlformats.org/drawingml/2006/main" noGrp="1"/>
+          </p:cNvSpPr>
+          <p:nvPr/>
+        </p:nvSpPr>
+        <p:spPr>
+          <a:xfrm xmlns:a="http://schemas.openxmlformats.org/drawingml/2006/main">
+            <a:off x="1790395" y="4926787"/>
+            <a:ext cx="3219602" cy="228600"/>
+          </a:xfrm>
+          <a:prstGeom xmlns:a="http://schemas.openxmlformats.org/drawingml/2006/main" prst="rect">
+            <a:avLst/>
+          </a:prstGeom>
+          <a:noFill xmlns:a="http://schemas.openxmlformats.org/drawingml/2006/main"/>
+        </p:spPr>
+        <p:txBody>
+          <a:bodyPr xmlns:a="http://schemas.openxmlformats.org/drawingml/2006/main" wrap="square" lIns="0" tIns="0" rIns="0" bIns="0" anchor="ctr"/>
+          <a:lstStyle xmlns:a="http://schemas.openxmlformats.org/drawingml/2006/main"/>
+          <a:p xmlns:a="http://schemas.openxmlformats.org/drawingml/2006/main">
+            <a:pPr marL="0" indent="0" algn="l">
+              <a:buNone/>
+            </a:pPr>
+            <a:r>
+              <a:rPr sz="1200">
+                <a:solidFill>
+                  <a:srgbClr val="FFFFFF">
+                    <a:alpha val="80000"/>
+                  </a:srgbClr>
+                </a:solidFill>
+                <a:latin typeface="Poppins"/>
+                <a:ea typeface="Poppins"/>
+                <a:cs typeface="Poppins"/>
+              </a:rPr>
+              <a:t>UCAN - Expansive Receptive Fields for Lightweight SR (CVPR 2026)</a:t>
+            </a:r>
+            <a:endParaRPr sz="1200"/>
+          </a:p>
+        </p:txBody>
+      </p:sp>
+      <p:sp>
+        <p:nvSpPr>
+          <p:cNvPr id="27" name="Shape 20">
+            <a:extLst xmlns:a="http://schemas.openxmlformats.org/drawingml/2006/main">
+              <a:ext uri="{FF2B5EF4-FFF2-40B4-BE49-F238E27FC236}">
+                <a16:creationId xmlns:a16="http://schemas.microsoft.com/office/drawing/2014/main" id="{D35B5B60-6271-4DAA-96D1-CC2DB3FF2B62}"/>
+              </a:ext>
+            </a:extLst>
+          </p:cNvPr>
+          <p:cNvSpPr>
+            <a:spLocks xmlns:a="http://schemas.openxmlformats.org/drawingml/2006/main" noGrp="1"/>
+          </p:cNvSpPr>
+          <p:nvPr/>
+        </p:nvSpPr>
+        <p:spPr>
+          <a:xfrm xmlns:a="http://schemas.openxmlformats.org/drawingml/2006/main">
+            <a:off x="1790395" y="5661050"/>
+            <a:ext cx="9277502" cy="9144"/>
+          </a:xfrm>
+          <a:prstGeom xmlns:a="http://schemas.openxmlformats.org/drawingml/2006/main" prst="rect">
+            <a:avLst/>
+          </a:prstGeom>
+          <a:solidFill xmlns:a="http://schemas.openxmlformats.org/drawingml/2006/main">
+            <a:srgbClr val="1E40AF">
+              <a:alpha val="30000"/>
+            </a:srgbClr>
+          </a:solidFill>
+        </p:spPr>
+        <p:txBody>
+          <a:bodyPr xmlns:a="http://schemas.openxmlformats.org/drawingml/2006/main"/>
+          <a:lstStyle xmlns:a="http://schemas.openxmlformats.org/drawingml/2006/main"/>
+          <a:p xmlns:a="http://schemas.openxmlformats.org/drawingml/2006/main">
+            <a:endParaRPr/>
+          </a:p>
+        </p:txBody>
+      </p:sp>
+      <p:sp>
+        <p:nvSpPr>
+          <p:cNvPr id="28" name="Text 21">
+            <a:extLst xmlns:a="http://schemas.openxmlformats.org/drawingml/2006/main">
+              <a:ext uri="{FF2B5EF4-FFF2-40B4-BE49-F238E27FC236}">
+                <a16:creationId xmlns:a16="http://schemas.microsoft.com/office/drawing/2014/main" id="{5F98A61B-0AA1-4CB1-B67A-4A38EFA7430D}"/>
+              </a:ext>
+            </a:extLst>
+          </p:cNvPr>
+          <p:cNvSpPr>
+            <a:spLocks xmlns:a="http://schemas.openxmlformats.org/drawingml/2006/main" noGrp="1"/>
+          </p:cNvSpPr>
+          <p:nvPr/>
+        </p:nvSpPr>
+        <p:spPr>
+          <a:xfrm xmlns:a="http://schemas.openxmlformats.org/drawingml/2006/main">
+            <a:off x="1790395" y="5355641"/>
+            <a:ext cx="3258007" cy="228600"/>
+          </a:xfrm>
+          <a:prstGeom xmlns:a="http://schemas.openxmlformats.org/drawingml/2006/main" prst="rect">
+            <a:avLst/>
+          </a:prstGeom>
+          <a:noFill xmlns:a="http://schemas.openxmlformats.org/drawingml/2006/main"/>
+        </p:spPr>
+        <p:txBody>
+          <a:bodyPr xmlns:a="http://schemas.openxmlformats.org/drawingml/2006/main" wrap="square" lIns="0" tIns="0" rIns="0" bIns="0" anchor="ctr"/>
+          <a:lstStyle xmlns:a="http://schemas.openxmlformats.org/drawingml/2006/main"/>
+          <a:p xmlns:a="http://schemas.openxmlformats.org/drawingml/2006/main">
+            <a:pPr marL="0" indent="0" algn="l">
+              <a:buNone/>
+            </a:pPr>
+            <a:r>
+              <a:rPr sz="1200">
+                <a:solidFill>
+                  <a:srgbClr val="FFFFFF">
+                    <a:alpha val="80000"/>
+                  </a:srgbClr>
+                </a:solidFill>
+                <a:latin typeface="Poppins"/>
+                <a:ea typeface="Poppins"/>
+                <a:cs typeface="Poppins"/>
+              </a:rPr>
+              <a:t>ShiftLUT - Spatial Shift Enhanced LUTs for Restoration (CVPR 2026)</a:t>
+            </a:r>
+            <a:endParaRPr sz="1200"/>
+          </a:p>
+        </p:txBody>
+      </p:sp>
+      <p:sp>
+        <p:nvSpPr>
+          <p:cNvPr id="29" name="Text 22">
+            <a:extLst xmlns:a="http://schemas.openxmlformats.org/drawingml/2006/main">
+              <a:ext uri="{FF2B5EF4-FFF2-40B4-BE49-F238E27FC236}">
+                <a16:creationId xmlns:a16="http://schemas.microsoft.com/office/drawing/2014/main" id="{5A7ADD0F-A618-47A5-BF65-348B65B28668}"/>
+              </a:ext>
+            </a:extLst>
+          </p:cNvPr>
+          <p:cNvSpPr>
+            <a:spLocks xmlns:a="http://schemas.openxmlformats.org/drawingml/2006/main" noGrp="1"/>
+          </p:cNvSpPr>
+          <p:nvPr/>
+        </p:nvSpPr>
+        <p:spPr>
+          <a:xfrm xmlns:a="http://schemas.openxmlformats.org/drawingml/2006/main">
+            <a:off x="1790395" y="5783580"/>
+            <a:ext cx="3258007" cy="228600"/>
+          </a:xfrm>
+          <a:prstGeom xmlns:a="http://schemas.openxmlformats.org/drawingml/2006/main" prst="rect">
+            <a:avLst/>
+          </a:prstGeom>
+          <a:noFill xmlns:a="http://schemas.openxmlformats.org/drawingml/2006/main"/>
+        </p:spPr>
+        <p:txBody>
+          <a:bodyPr xmlns:a="http://schemas.openxmlformats.org/drawingml/2006/main" wrap="square" lIns="0" tIns="0" rIns="0" bIns="0" anchor="ctr"/>
+          <a:lstStyle xmlns:a="http://schemas.openxmlformats.org/drawingml/2006/main"/>
+          <a:p xmlns:a="http://schemas.openxmlformats.org/drawingml/2006/main">
+            <a:pPr marL="0" indent="0" algn="l">
+              <a:buNone/>
+            </a:pPr>
+            <a:r>
+              <a:rPr sz="1200">
+                <a:solidFill>
+                  <a:srgbClr val="FFFFFF">
+                    <a:alpha val="80000"/>
+                  </a:srgbClr>
+                </a:solidFill>
+                <a:latin typeface="Poppins"/>
+                <a:ea typeface="Poppins"/>
+                <a:cs typeface="Poppins"/>
+              </a:rPr>
+              <a:t>I4C Hackathon 2026 challenge and released paired dataset (i4c.in)</a:t>
+            </a:r>
+            <a:endParaRPr sz="1200"/>
+          </a:p>
+        </p:txBody>
+      </p:sp>
+      <p:pic>
+        <p:nvPicPr>
+          <p:cNvPr id="68" name="Picture 29"/>
+          <p:cNvPicPr>
+            <a:picLocks xmlns:a="http://schemas.openxmlformats.org/drawingml/2006/main" noChangeAspect="1"/>
+          </p:cNvPicPr>
+          <p:nvPr/>
+        </p:nvPicPr>
+        <p:blipFill>
+          <a:blip xmlns:r="http://schemas.openxmlformats.org/officeDocument/2006/relationships" xmlns:a="http://schemas.openxmlformats.org/drawingml/2006/main" r:embed="R5e1489bab4ce4354"/>
+          <a:stretch xmlns:a="http://schemas.openxmlformats.org/drawingml/2006/main">
+            <a:fillRect l="0" t="0" r="0" b="0"/>
+          </a:stretch>
+        </p:blipFill>
+        <p:spPr>
+          <a:xfrm xmlns:a="http://schemas.openxmlformats.org/drawingml/2006/main">
+            <a:off x="5292164" y="227710"/>
+            <a:ext cx="1607366" cy="783591"/>
+          </a:xfrm>
+          <a:prstGeom xmlns:a="http://schemas.openxmlformats.org/drawingml/2006/main" prst="rect">
+            <a:avLst/>
+          </a:prstGeom>
+        </p:spPr>
+      </p:pic>
+      <p:sp>
+        <p:nvSpPr>
+          <p:cNvPr id="32" name="Shape 1">
+            <a:extLst xmlns:a="http://schemas.openxmlformats.org/drawingml/2006/main">
+              <a:ext uri="{FF2B5EF4-FFF2-40B4-BE49-F238E27FC236}">
+                <a16:creationId xmlns:a16="http://schemas.microsoft.com/office/drawing/2014/main" id="{3E27E131-AC1D-E75C-0267-02565ACC1BC3}"/>
+              </a:ext>
+            </a:extLst>
+          </p:cNvPr>
+          <p:cNvSpPr>
+            <a:spLocks xmlns:a="http://schemas.openxmlformats.org/drawingml/2006/main" noGrp="1"/>
+          </p:cNvSpPr>
+          <p:nvPr/>
+        </p:nvSpPr>
+        <p:spPr>
+          <a:xfrm xmlns:a="http://schemas.openxmlformats.org/drawingml/2006/main">
+            <a:off x="571500" y="259714"/>
+            <a:ext cx="11048695" cy="857707"/>
+          </a:xfrm>
+          <a:prstGeom xmlns:a="http://schemas.openxmlformats.org/drawingml/2006/main" prst="roundRect">
+            <a:avLst>
+              <a:gd name="adj" fmla="val 9476"/>
+            </a:avLst>
+          </a:prstGeom>
+          <a:solidFill xmlns:a="http://schemas.openxmlformats.org/drawingml/2006/main">
+            <a:srgbClr val="FFFFFF">
+              <a:alpha val="95000"/>
+            </a:srgbClr>
+          </a:solidFill>
+          <a:effectLst xmlns:a="http://schemas.openxmlformats.org/drawingml/2006/main">
+            <a:outerShdw blurRad="63500" dist="38100" dir="5400000" algn="bl" rotWithShape="0">
+              <a:srgbClr val="000000">
+                <a:alpha val="10000"/>
+              </a:srgbClr>
+            </a:outerShdw>
+          </a:effectLst>
+        </p:spPr>
+        <p:txBody>
+          <a:bodyPr xmlns:a="http://schemas.openxmlformats.org/drawingml/2006/main"/>
+          <a:lstStyle xmlns:a="http://schemas.openxmlformats.org/drawingml/2006/main"/>
+          <a:p xmlns:a="http://schemas.openxmlformats.org/drawingml/2006/main">
+            <a:endParaRPr/>
+          </a:p>
+        </p:txBody>
+      </p:sp>
+      <p:pic>
+        <p:nvPicPr>
+          <p:cNvPr id="70" name="Picture 32"/>
+          <p:cNvPicPr>
+            <a:picLocks xmlns:a="http://schemas.openxmlformats.org/drawingml/2006/main" noChangeAspect="1"/>
+          </p:cNvPicPr>
+          <p:nvPr/>
+        </p:nvPicPr>
+        <p:blipFill>
+          <a:blip xmlns:r="http://schemas.openxmlformats.org/officeDocument/2006/relationships" xmlns:a="http://schemas.openxmlformats.org/drawingml/2006/main" r:embed="R02a4233f212a4117"/>
+          <a:stretch xmlns:a="http://schemas.openxmlformats.org/drawingml/2006/main">
+            <a:fillRect l="0" t="0" r="0" b="0"/>
+          </a:stretch>
+        </p:blipFill>
+        <p:spPr>
+          <a:xfrm xmlns:a="http://schemas.openxmlformats.org/drawingml/2006/main">
+            <a:off x="1514101" y="390016"/>
+            <a:ext cx="9163491" cy="586435"/>
+          </a:xfrm>
+          <a:prstGeom xmlns:a="http://schemas.openxmlformats.org/drawingml/2006/main" prst="rect">
+            <a:avLst/>
+          </a:prstGeom>
+        </p:spPr>
+      </p:pic>
+    </p:spTree>
+    <p:extLst>
+      <p:ext uri="{BB962C8B-B14F-4D97-AF65-F5344CB8AC3E}">
+        <p14:creationId xmlns:p14="http://schemas.microsoft.com/office/powerpoint/2010/main" val="1067614550"/>
+      </p:ext>
+    </p:extLst>
+  </p:cSld>
 </p:sld>
 </file>
 

</xml_diff>